<commit_message>
📰 Pulse update 2026-03-15
</commit_message>
<xml_diff>
--- a/data/archive/pulse_2026-03-15.pptx
+++ b/data/archive/pulse_2026-03-15.pptx
@@ -21,7 +21,6 @@
     <p:sldId id="269" r:id="rId20"/>
     <p:sldId id="270" r:id="rId21"/>
     <p:sldId id="271" r:id="rId22"/>
-    <p:sldId id="272" r:id="rId23"/>
   </p:sldIdLst>
   <p:sldSz cx="12191695" cy="6858000" type="screen4x3"/>
   <p:notesSz cx="6858000" cy="9144000"/>
@@ -3304,7 +3303,7 @@
             <a:avLst/>
           </a:prstGeom>
           <a:solidFill>
-            <a:srgbClr val="EF4444"/>
+            <a:srgbClr val="059669"/>
           </a:solidFill>
           <a:ln>
             <a:noFill/>
@@ -3357,13 +3356,13 @@
             <a:pPr algn="l">
               <a:defRPr sz="1000" b="1">
                 <a:solidFill>
-                  <a:srgbClr val="EF4444"/>
-                </a:solidFill>
-                <a:latin typeface="Calibri"/>
-              </a:defRPr>
-            </a:pPr>
-            <a:r>
-              <a:t>🔥  CLAPS</a:t>
+                  <a:srgbClr val="059669"/>
+                </a:solidFill>
+                <a:latin typeface="Calibri"/>
+              </a:defRPr>
+            </a:pPr>
+            <a:r>
+              <a:t>💰  MILESTONE</a:t>
             </a:r>
           </a:p>
         </p:txBody>
@@ -3393,13 +3392,13 @@
             <a:pPr algn="l">
               <a:defRPr sz="3200" b="1" i="0">
                 <a:solidFill>
-                  <a:srgbClr val="EF4444"/>
-                </a:solidFill>
-                <a:latin typeface="Calibri"/>
-              </a:defRPr>
-            </a:pPr>
-            <a:r>
-              <a:t>Product Development</a:t>
+                  <a:srgbClr val="059669"/>
+                </a:solidFill>
+                <a:latin typeface="Calibri"/>
+              </a:defRPr>
+            </a:pPr>
+            <a:r>
+              <a:t>Company Growth</a:t>
             </a:r>
           </a:p>
         </p:txBody>
@@ -3413,29 +3412,29 @@
         <p:spPr>
           <a:xfrm>
             <a:off x="1097280" y="2103120"/>
-            <a:ext cx="2743200" cy="548640"/>
-          </a:xfrm>
-          <a:prstGeom prst="rect">
-            <a:avLst/>
-          </a:prstGeom>
-          <a:noFill/>
-        </p:spPr>
-        <p:txBody>
-          <a:bodyPr wrap="square">
-            <a:spAutoFit/>
-          </a:bodyPr>
-          <a:lstStyle/>
-          <a:p>
-            <a:pPr algn="l">
-              <a:defRPr sz="2800" b="1" i="0">
-                <a:solidFill>
-                  <a:srgbClr val="EF4444"/>
-                </a:solidFill>
-                <a:latin typeface="Calibri"/>
-              </a:defRPr>
-            </a:pPr>
-            <a:r>
-              <a:t>22</a:t>
+            <a:ext cx="4572000" cy="822960"/>
+          </a:xfrm>
+          <a:prstGeom prst="rect">
+            <a:avLst/>
+          </a:prstGeom>
+          <a:noFill/>
+        </p:spPr>
+        <p:txBody>
+          <a:bodyPr wrap="square">
+            <a:spAutoFit/>
+          </a:bodyPr>
+          <a:lstStyle/>
+          <a:p>
+            <a:pPr algn="l">
+              <a:defRPr sz="5200" b="1" i="0">
+                <a:solidFill>
+                  <a:srgbClr val="059669"/>
+                </a:solidFill>
+                <a:latin typeface="Calibri"/>
+              </a:defRPr>
+            </a:pPr>
+            <a:r>
+              <a:t>$100M</a:t>
             </a:r>
           </a:p>
         </p:txBody>
@@ -3448,22 +3447,94 @@
         </p:nvSpPr>
         <p:spPr>
           <a:xfrm>
-            <a:off x="1097280" y="2651760"/>
-            <a:ext cx="9966960" cy="365760"/>
-          </a:xfrm>
-          <a:prstGeom prst="rect">
-            <a:avLst/>
-          </a:prstGeom>
-          <a:noFill/>
-        </p:spPr>
-        <p:txBody>
-          <a:bodyPr wrap="square">
-            <a:spAutoFit/>
-          </a:bodyPr>
-          <a:lstStyle/>
-          <a:p>
-            <a:pPr algn="l">
-              <a:defRPr sz="1400" b="0" i="0">
+            <a:off x="1097280" y="2926080"/>
+            <a:ext cx="4572000" cy="365760"/>
+          </a:xfrm>
+          <a:prstGeom prst="rect">
+            <a:avLst/>
+          </a:prstGeom>
+          <a:noFill/>
+        </p:spPr>
+        <p:txBody>
+          <a:bodyPr wrap="square">
+            <a:spAutoFit/>
+          </a:bodyPr>
+          <a:lstStyle/>
+          <a:p>
+            <a:pPr algn="l">
+              <a:defRPr sz="1100" b="0" i="0">
+                <a:solidFill>
+                  <a:srgbClr val="8F95A3"/>
+                </a:solidFill>
+                <a:latin typeface="Calibri"/>
+              </a:defRPr>
+            </a:pPr>
+            <a:r>
+              <a:t>Gross Profit with 40% YoY Growth</a:t>
+            </a:r>
+          </a:p>
+        </p:txBody>
+      </p:sp>
+      <p:sp>
+        <p:nvSpPr>
+          <p:cNvPr id="7" name="TextBox 6"/>
+          <p:cNvSpPr txBox="1"/>
+          <p:nvPr/>
+        </p:nvSpPr>
+        <p:spPr>
+          <a:xfrm>
+            <a:off x="1097280" y="3566160"/>
+            <a:ext cx="9966960" cy="457200"/>
+          </a:xfrm>
+          <a:prstGeom prst="rect">
+            <a:avLst/>
+          </a:prstGeom>
+          <a:noFill/>
+        </p:spPr>
+        <p:txBody>
+          <a:bodyPr wrap="square">
+            <a:spAutoFit/>
+          </a:bodyPr>
+          <a:lstStyle/>
+          <a:p>
+            <a:pPr algn="l">
+              <a:defRPr sz="1800" b="1" i="0">
+                <a:solidFill>
+                  <a:srgbClr val="FFFFFF"/>
+                </a:solidFill>
+                <a:latin typeface="Calibri"/>
+              </a:defRPr>
+            </a:pPr>
+            <a:r>
+              <a:t>Impressive financial trajectory</a:t>
+            </a:r>
+          </a:p>
+        </p:txBody>
+      </p:sp>
+      <p:sp>
+        <p:nvSpPr>
+          <p:cNvPr id="8" name="TextBox 7"/>
+          <p:cNvSpPr txBox="1"/>
+          <p:nvPr/>
+        </p:nvSpPr>
+        <p:spPr>
+          <a:xfrm>
+            <a:off x="1097280" y="4206240"/>
+            <a:ext cx="9966960" cy="1371600"/>
+          </a:xfrm>
+          <a:prstGeom prst="rect">
+            <a:avLst/>
+          </a:prstGeom>
+          <a:noFill/>
+        </p:spPr>
+        <p:txBody>
+          <a:bodyPr wrap="square">
+            <a:spAutoFit/>
+          </a:bodyPr>
+          <a:lstStyle/>
+          <a:p>
+            <a:pPr algn="l">
+              <a:defRPr sz="1500" b="0" i="0">
                 <a:solidFill>
                   <a:srgbClr val="E2E2EA"/>
                 </a:solidFill>
@@ -3471,115 +3542,7 @@
               </a:defRPr>
             </a:pPr>
             <a:r>
-              <a:t>from Maxim Sinyaev &amp; Agustin &amp; Sergio-Yersi Villegas</a:t>
-            </a:r>
-          </a:p>
-        </p:txBody>
-      </p:sp>
-      <p:sp>
-        <p:nvSpPr>
-          <p:cNvPr id="7" name="TextBox 6"/>
-          <p:cNvSpPr txBox="1"/>
-          <p:nvPr/>
-        </p:nvSpPr>
-        <p:spPr>
-          <a:xfrm>
-            <a:off x="1097280" y="3108960"/>
-            <a:ext cx="9966960" cy="365760"/>
-          </a:xfrm>
-          <a:prstGeom prst="rect">
-            <a:avLst/>
-          </a:prstGeom>
-          <a:noFill/>
-        </p:spPr>
-        <p:txBody>
-          <a:bodyPr wrap="square">
-            <a:spAutoFit/>
-          </a:bodyPr>
-          <a:lstStyle/>
-          <a:p>
-            <a:pPr algn="l">
-              <a:defRPr sz="1400" b="1" i="0">
-                <a:solidFill>
-                  <a:srgbClr val="FFFFFF"/>
-                </a:solidFill>
-                <a:latin typeface="Calibri"/>
-              </a:defRPr>
-            </a:pPr>
-            <a:r>
-              <a:t>to: Agustin, Sem Sinchenko, Emil Sharafiev, Alessandro, Antonio Clavelli, Wojo</a:t>
-            </a:r>
-          </a:p>
-        </p:txBody>
-      </p:sp>
-      <p:sp>
-        <p:nvSpPr>
-          <p:cNvPr id="8" name="TextBox 7"/>
-          <p:cNvSpPr txBox="1"/>
-          <p:nvPr/>
-        </p:nvSpPr>
-        <p:spPr>
-          <a:xfrm>
-            <a:off x="1097280" y="3749039"/>
-            <a:ext cx="9966960" cy="1097280"/>
-          </a:xfrm>
-          <a:prstGeom prst="rect">
-            <a:avLst/>
-          </a:prstGeom>
-          <a:noFill/>
-        </p:spPr>
-        <p:txBody>
-          <a:bodyPr wrap="square">
-            <a:spAutoFit/>
-          </a:bodyPr>
-          <a:lstStyle/>
-          <a:p>
-            <a:pPr algn="l">
-              <a:defRPr sz="1500" b="0" i="1">
-                <a:solidFill>
-                  <a:srgbClr val="E2E2EA"/>
-                </a:solidFill>
-                <a:latin typeface="Calibri"/>
-              </a:defRPr>
-            </a:pPr>
-            <a:r>
-              <a:t>"Driving product innovation and development forward with incredible energy"</a:t>
-            </a:r>
-          </a:p>
-        </p:txBody>
-      </p:sp>
-      <p:sp>
-        <p:nvSpPr>
-          <p:cNvPr id="9" name="TextBox 8"/>
-          <p:cNvSpPr txBox="1"/>
-          <p:nvPr/>
-        </p:nvSpPr>
-        <p:spPr>
-          <a:xfrm>
-            <a:off x="1097280" y="5120640"/>
-            <a:ext cx="9966960" cy="457200"/>
-          </a:xfrm>
-          <a:prstGeom prst="rect">
-            <a:avLst/>
-          </a:prstGeom>
-          <a:noFill/>
-        </p:spPr>
-        <p:txBody>
-          <a:bodyPr wrap="square">
-            <a:spAutoFit/>
-          </a:bodyPr>
-          <a:lstStyle/>
-          <a:p>
-            <a:pPr algn="l">
-              <a:defRPr sz="1200" b="1" i="0">
-                <a:solidFill>
-                  <a:srgbClr val="EF4444"/>
-                </a:solidFill>
-                <a:latin typeface="Calibri"/>
-              </a:defRPr>
-            </a:pPr>
-            <a:r>
-              <a:t>Innovation · Drive</a:t>
+              <a:t>Strong fundamentals driving sustainable expansion across all business units</a:t>
             </a:r>
           </a:p>
         </p:txBody>
@@ -3625,7 +3588,7 @@
             <a:avLst/>
           </a:prstGeom>
           <a:solidFill>
-            <a:srgbClr val="F59E0B"/>
+            <a:srgbClr val="7C3AED"/>
           </a:solidFill>
           <a:ln>
             <a:noFill/>
@@ -3678,13 +3641,13 @@
             <a:pPr algn="l">
               <a:defRPr sz="1000" b="1">
                 <a:solidFill>
-                  <a:srgbClr val="F59E0B"/>
-                </a:solidFill>
-                <a:latin typeface="Calibri"/>
-              </a:defRPr>
-            </a:pPr>
-            <a:r>
-              <a:t>⚡  CLAPS</a:t>
+                  <a:srgbClr val="7C3AED"/>
+                </a:solidFill>
+                <a:latin typeface="Calibri"/>
+              </a:defRPr>
+            </a:pPr>
+            <a:r>
+              <a:t>🤖  WIN</a:t>
             </a:r>
           </a:p>
         </p:txBody>
@@ -3714,13 +3677,13 @@
             <a:pPr algn="l">
               <a:defRPr sz="3200" b="1" i="0">
                 <a:solidFill>
-                  <a:srgbClr val="F59E0B"/>
-                </a:solidFill>
-                <a:latin typeface="Calibri"/>
-              </a:defRPr>
-            </a:pPr>
-            <a:r>
-              <a:t>DevOps Excellence</a:t>
+                  <a:srgbClr val="7C3AED"/>
+                </a:solidFill>
+                <a:latin typeface="Calibri"/>
+              </a:defRPr>
+            </a:pPr>
+            <a:r>
+              <a:t>AI Revolution</a:t>
             </a:r>
           </a:p>
         </p:txBody>
@@ -3734,29 +3697,29 @@
         <p:spPr>
           <a:xfrm>
             <a:off x="1097280" y="2103120"/>
-            <a:ext cx="2743200" cy="548640"/>
-          </a:xfrm>
-          <a:prstGeom prst="rect">
-            <a:avLst/>
-          </a:prstGeom>
-          <a:noFill/>
-        </p:spPr>
-        <p:txBody>
-          <a:bodyPr wrap="square">
-            <a:spAutoFit/>
-          </a:bodyPr>
-          <a:lstStyle/>
-          <a:p>
-            <a:pPr algn="l">
-              <a:defRPr sz="2800" b="1" i="0">
-                <a:solidFill>
-                  <a:srgbClr val="F59E0B"/>
-                </a:solidFill>
-                <a:latin typeface="Calibri"/>
-              </a:defRPr>
-            </a:pPr>
-            <a:r>
-              <a:t>19</a:t>
+            <a:ext cx="4572000" cy="822960"/>
+          </a:xfrm>
+          <a:prstGeom prst="rect">
+            <a:avLst/>
+          </a:prstGeom>
+          <a:noFill/>
+        </p:spPr>
+        <p:txBody>
+          <a:bodyPr wrap="square">
+            <a:spAutoFit/>
+          </a:bodyPr>
+          <a:lstStyle/>
+          <a:p>
+            <a:pPr algn="l">
+              <a:defRPr sz="4800" b="1" i="0">
+                <a:solidFill>
+                  <a:srgbClr val="7C3AED"/>
+                </a:solidFill>
+                <a:latin typeface="Calibri"/>
+              </a:defRPr>
+            </a:pPr>
+            <a:r>
+              <a:t>5-10</a:t>
             </a:r>
           </a:p>
         </p:txBody>
@@ -3769,7 +3732,43 @@
         </p:nvSpPr>
         <p:spPr>
           <a:xfrm>
-            <a:off x="1097280" y="2651760"/>
+            <a:off x="1097280" y="2834640"/>
+            <a:ext cx="4572000" cy="365760"/>
+          </a:xfrm>
+          <a:prstGeom prst="rect">
+            <a:avLst/>
+          </a:prstGeom>
+          <a:noFill/>
+        </p:spPr>
+        <p:txBody>
+          <a:bodyPr wrap="square">
+            <a:spAutoFit/>
+          </a:bodyPr>
+          <a:lstStyle/>
+          <a:p>
+            <a:pPr algn="l">
+              <a:defRPr sz="1200" b="0" i="0">
+                <a:solidFill>
+                  <a:srgbClr val="8F95A3"/>
+                </a:solidFill>
+                <a:latin typeface="Calibri"/>
+              </a:defRPr>
+            </a:pPr>
+            <a:r>
+              <a:t>AI Agents per Person</a:t>
+            </a:r>
+          </a:p>
+        </p:txBody>
+      </p:sp>
+      <p:sp>
+        <p:nvSpPr>
+          <p:cNvPr id="7" name="TextBox 6"/>
+          <p:cNvSpPr txBox="1"/>
+          <p:nvPr/>
+        </p:nvSpPr>
+        <p:spPr>
+          <a:xfrm>
+            <a:off x="1097280" y="3291840"/>
             <a:ext cx="9966960" cy="365760"/>
           </a:xfrm>
           <a:prstGeom prst="rect">
@@ -3792,35 +3791,35 @@
               </a:defRPr>
             </a:pPr>
             <a:r>
-              <a:t>from Dzmitry Baran &amp; anton.nikifarau &amp; Isahakyan</a:t>
-            </a:r>
-          </a:p>
-        </p:txBody>
-      </p:sp>
-      <p:sp>
-        <p:nvSpPr>
-          <p:cNvPr id="7" name="TextBox 6"/>
-          <p:cNvSpPr txBox="1"/>
-          <p:nvPr/>
-        </p:nvSpPr>
-        <p:spPr>
-          <a:xfrm>
-            <a:off x="1097280" y="3108960"/>
-            <a:ext cx="9966960" cy="365760"/>
-          </a:xfrm>
-          <a:prstGeom prst="rect">
-            <a:avLst/>
-          </a:prstGeom>
-          <a:noFill/>
-        </p:spPr>
-        <p:txBody>
-          <a:bodyPr wrap="square">
-            <a:spAutoFit/>
-          </a:bodyPr>
-          <a:lstStyle/>
-          <a:p>
-            <a:pPr algn="l">
-              <a:defRPr sz="1400" b="1" i="0">
+              <a:t>by Every Employee</a:t>
+            </a:r>
+          </a:p>
+        </p:txBody>
+      </p:sp>
+      <p:sp>
+        <p:nvSpPr>
+          <p:cNvPr id="8" name="TextBox 7"/>
+          <p:cNvSpPr txBox="1"/>
+          <p:nvPr/>
+        </p:nvSpPr>
+        <p:spPr>
+          <a:xfrm>
+            <a:off x="1097280" y="3840480"/>
+            <a:ext cx="9966960" cy="457200"/>
+          </a:xfrm>
+          <a:prstGeom prst="rect">
+            <a:avLst/>
+          </a:prstGeom>
+          <a:noFill/>
+        </p:spPr>
+        <p:txBody>
+          <a:bodyPr wrap="square">
+            <a:spAutoFit/>
+          </a:bodyPr>
+          <a:lstStyle/>
+          <a:p>
+            <a:pPr algn="l">
+              <a:defRPr sz="1800" b="1" i="0">
                 <a:solidFill>
                   <a:srgbClr val="FFFFFF"/>
                 </a:solidFill>
@@ -3828,35 +3827,35 @@
               </a:defRPr>
             </a:pPr>
             <a:r>
-              <a:t>to: Aleh Mentuz, Ivan Litvinau, Anna Hrytsel, Mikita Dzianisevich, stas.k, Petr Chebanov, Cagatay Akcam, Viktar Plesko, Vladislav Nikolaev</a:t>
-            </a:r>
-          </a:p>
-        </p:txBody>
-      </p:sp>
-      <p:sp>
-        <p:nvSpPr>
-          <p:cNvPr id="8" name="TextBox 7"/>
-          <p:cNvSpPr txBox="1"/>
-          <p:nvPr/>
-        </p:nvSpPr>
-        <p:spPr>
-          <a:xfrm>
-            <a:off x="1097280" y="3749039"/>
-            <a:ext cx="9966960" cy="1097280"/>
-          </a:xfrm>
-          <a:prstGeom prst="rect">
-            <a:avLst/>
-          </a:prstGeom>
-          <a:noFill/>
-        </p:spPr>
-        <p:txBody>
-          <a:bodyPr wrap="square">
-            <a:spAutoFit/>
-          </a:bodyPr>
-          <a:lstStyle/>
-          <a:p>
-            <a:pPr algn="l">
-              <a:defRPr sz="1500" b="0" i="1">
+              <a:t>Transforming how we work with AI</a:t>
+            </a:r>
+          </a:p>
+        </p:txBody>
+      </p:sp>
+      <p:sp>
+        <p:nvSpPr>
+          <p:cNvPr id="9" name="TextBox 8"/>
+          <p:cNvSpPr txBox="1"/>
+          <p:nvPr/>
+        </p:nvSpPr>
+        <p:spPr>
+          <a:xfrm>
+            <a:off x="1097280" y="4389120"/>
+            <a:ext cx="9966960" cy="914400"/>
+          </a:xfrm>
+          <a:prstGeom prst="rect">
+            <a:avLst/>
+          </a:prstGeom>
+          <a:noFill/>
+        </p:spPr>
+        <p:txBody>
+          <a:bodyPr wrap="square">
+            <a:spAutoFit/>
+          </a:bodyPr>
+          <a:lstStyle/>
+          <a:p>
+            <a:pPr algn="l">
+              <a:defRPr sz="1400" b="0" i="0">
                 <a:solidFill>
                   <a:srgbClr val="E2E2EA"/>
                 </a:solidFill>
@@ -3864,20 +3863,20 @@
               </a:defRPr>
             </a:pPr>
             <a:r>
-              <a:t>"Maintaining infrastructure excellence and supporting team productivity"</a:t>
-            </a:r>
-          </a:p>
-        </p:txBody>
-      </p:sp>
-      <p:sp>
-        <p:nvSpPr>
-          <p:cNvPr id="9" name="TextBox 8"/>
-          <p:cNvSpPr txBox="1"/>
-          <p:nvPr/>
-        </p:nvSpPr>
-        <p:spPr>
-          <a:xfrm>
-            <a:off x="1097280" y="5120640"/>
+              <a:t>Within 3-6 months, every team member will manage multiple AI agents, fundamentally changing our productivity and capabilities.</a:t>
+            </a:r>
+          </a:p>
+        </p:txBody>
+      </p:sp>
+      <p:sp>
+        <p:nvSpPr>
+          <p:cNvPr id="10" name="TextBox 9"/>
+          <p:cNvSpPr txBox="1"/>
+          <p:nvPr/>
+        </p:nvSpPr>
+        <p:spPr>
+          <a:xfrm>
+            <a:off x="1097280" y="5486400"/>
             <a:ext cx="9966960" cy="457200"/>
           </a:xfrm>
           <a:prstGeom prst="rect">
@@ -3892,15 +3891,15 @@
           <a:lstStyle/>
           <a:p>
             <a:pPr algn="l">
-              <a:defRPr sz="1200" b="1" i="0">
-                <a:solidFill>
-                  <a:srgbClr val="F59E0B"/>
-                </a:solidFill>
-                <a:latin typeface="Calibri"/>
-              </a:defRPr>
-            </a:pPr>
-            <a:r>
-              <a:t>Reliability · Support</a:t>
+              <a:defRPr sz="1300" b="0" i="1">
+                <a:solidFill>
+                  <a:srgbClr val="8F95A3"/>
+                </a:solidFill>
+                <a:latin typeface="Calibri"/>
+              </a:defRPr>
+            </a:pPr>
+            <a:r>
+              <a:t>💬 "We're not just using AI—we're building the future of work"</a:t>
             </a:r>
           </a:p>
         </p:txBody>
@@ -3946,7 +3945,7 @@
             <a:avLst/>
           </a:prstGeom>
           <a:solidFill>
-            <a:srgbClr val="10B981"/>
+            <a:srgbClr val="DC2626"/>
           </a:solidFill>
           <a:ln>
             <a:noFill/>
@@ -3999,13 +3998,13 @@
             <a:pPr algn="l">
               <a:defRPr sz="1000" b="1">
                 <a:solidFill>
-                  <a:srgbClr val="10B981"/>
-                </a:solidFill>
-                <a:latin typeface="Calibri"/>
-              </a:defRPr>
-            </a:pPr>
-            <a:r>
-              <a:t>💰  MILESTONE</a:t>
+                  <a:srgbClr val="DC2626"/>
+                </a:solidFill>
+                <a:latin typeface="Calibri"/>
+              </a:defRPr>
+            </a:pPr>
+            <a:r>
+              <a:t>🎯  WIN</a:t>
             </a:r>
           </a:p>
         </p:txBody>
@@ -4035,13 +4034,13 @@
             <a:pPr algn="l">
               <a:defRPr sz="3200" b="1" i="0">
                 <a:solidFill>
-                  <a:srgbClr val="10B981"/>
-                </a:solidFill>
-                <a:latin typeface="Calibri"/>
-              </a:defRPr>
-            </a:pPr>
-            <a:r>
-              <a:t>Financial Excellence</a:t>
+                  <a:srgbClr val="DC2626"/>
+                </a:solidFill>
+                <a:latin typeface="Calibri"/>
+              </a:defRPr>
+            </a:pPr>
+            <a:r>
+              <a:t>Fraud Prevention Victory</a:t>
             </a:r>
           </a:p>
         </p:txBody>
@@ -4069,15 +4068,15 @@
           <a:lstStyle/>
           <a:p>
             <a:pPr algn="l">
-              <a:defRPr sz="5200" b="1" i="0">
-                <a:solidFill>
-                  <a:srgbClr val="10B981"/>
-                </a:solidFill>
-                <a:latin typeface="Calibri"/>
-              </a:defRPr>
-            </a:pPr>
-            <a:r>
-              <a:t>$100M</a:t>
+              <a:defRPr sz="4800" b="1" i="0">
+                <a:solidFill>
+                  <a:srgbClr val="DC2626"/>
+                </a:solidFill>
+                <a:latin typeface="Calibri"/>
+              </a:defRPr>
+            </a:pPr>
+            <a:r>
+              <a:t>22% → 4%</a:t>
             </a:r>
           </a:p>
         </p:txBody>
@@ -4090,7 +4089,7 @@
         </p:nvSpPr>
         <p:spPr>
           <a:xfrm>
-            <a:off x="1097280" y="2926080"/>
+            <a:off x="1097280" y="2834640"/>
             <a:ext cx="4572000" cy="365760"/>
           </a:xfrm>
           <a:prstGeom prst="rect">
@@ -4105,7 +4104,7 @@
           <a:lstStyle/>
           <a:p>
             <a:pPr algn="l">
-              <a:defRPr sz="1100" b="0" i="0">
+              <a:defRPr sz="1200" b="0" i="0">
                 <a:solidFill>
                   <a:srgbClr val="8F95A3"/>
                 </a:solidFill>
@@ -4113,7 +4112,7 @@
               </a:defRPr>
             </a:pPr>
             <a:r>
-              <a:t>Gross Profit</a:t>
+              <a:t>Fraud Rate Reduction</a:t>
             </a:r>
           </a:p>
         </p:txBody>
@@ -4126,7 +4125,43 @@
         </p:nvSpPr>
         <p:spPr>
           <a:xfrm>
-            <a:off x="1097280" y="3566160"/>
+            <a:off x="1097280" y="3291840"/>
+            <a:ext cx="9966960" cy="365760"/>
+          </a:xfrm>
+          <a:prstGeom prst="rect">
+            <a:avLst/>
+          </a:prstGeom>
+          <a:noFill/>
+        </p:spPr>
+        <p:txBody>
+          <a:bodyPr wrap="square">
+            <a:spAutoFit/>
+          </a:bodyPr>
+          <a:lstStyle/>
+          <a:p>
+            <a:pPr algn="l">
+              <a:defRPr sz="1400" b="0" i="0">
+                <a:solidFill>
+                  <a:srgbClr val="E2E2EA"/>
+                </a:solidFill>
+                <a:latin typeface="Calibri"/>
+              </a:defRPr>
+            </a:pPr>
+            <a:r>
+              <a:t>by Security Team</a:t>
+            </a:r>
+          </a:p>
+        </p:txBody>
+      </p:sp>
+      <p:sp>
+        <p:nvSpPr>
+          <p:cNvPr id="8" name="TextBox 7"/>
+          <p:cNvSpPr txBox="1"/>
+          <p:nvPr/>
+        </p:nvSpPr>
+        <p:spPr>
+          <a:xfrm>
+            <a:off x="1097280" y="3840480"/>
             <a:ext cx="9966960" cy="457200"/>
           </a:xfrm>
           <a:prstGeom prst="rect">
@@ -4149,35 +4184,35 @@
               </a:defRPr>
             </a:pPr>
             <a:r>
-              <a:t>Exceptional Growth Trajectory</a:t>
-            </a:r>
-          </a:p>
-        </p:txBody>
-      </p:sp>
-      <p:sp>
-        <p:nvSpPr>
-          <p:cNvPr id="8" name="TextBox 7"/>
-          <p:cNvSpPr txBox="1"/>
-          <p:nvPr/>
-        </p:nvSpPr>
-        <p:spPr>
-          <a:xfrm>
-            <a:off x="1097280" y="4206240"/>
-            <a:ext cx="9966960" cy="1371600"/>
-          </a:xfrm>
-          <a:prstGeom prst="rect">
-            <a:avLst/>
-          </a:prstGeom>
-          <a:noFill/>
-        </p:spPr>
-        <p:txBody>
-          <a:bodyPr wrap="square">
-            <a:spAutoFit/>
-          </a:bodyPr>
-          <a:lstStyle/>
-          <a:p>
-            <a:pPr algn="l">
-              <a:defRPr sz="1500" b="0" i="0">
+              <a:t>Massive fraud reduction achieved</a:t>
+            </a:r>
+          </a:p>
+        </p:txBody>
+      </p:sp>
+      <p:sp>
+        <p:nvSpPr>
+          <p:cNvPr id="9" name="TextBox 8"/>
+          <p:cNvSpPr txBox="1"/>
+          <p:nvPr/>
+        </p:nvSpPr>
+        <p:spPr>
+          <a:xfrm>
+            <a:off x="1097280" y="4389120"/>
+            <a:ext cx="9966960" cy="914400"/>
+          </a:xfrm>
+          <a:prstGeom prst="rect">
+            <a:avLst/>
+          </a:prstGeom>
+          <a:noFill/>
+        </p:spPr>
+        <p:txBody>
+          <a:bodyPr wrap="square">
+            <a:spAutoFit/>
+          </a:bodyPr>
+          <a:lstStyle/>
+          <a:p>
+            <a:pPr algn="l">
+              <a:defRPr sz="1400" b="0" i="0">
                 <a:solidFill>
                   <a:srgbClr val="E2E2EA"/>
                 </a:solidFill>
@@ -4185,7 +4220,43 @@
               </a:defRPr>
             </a:pPr>
             <a:r>
-              <a:t>Company achieving $100M gross profit with $20M EBITDA, projecting 40% year-over-year growth</a:t>
+              <a:t>Dynamic SDK signatures have dramatically cut fraud from 22% to under 4%, protecting our revenue and partner trust.</a:t>
+            </a:r>
+          </a:p>
+        </p:txBody>
+      </p:sp>
+      <p:sp>
+        <p:nvSpPr>
+          <p:cNvPr id="10" name="TextBox 9"/>
+          <p:cNvSpPr txBox="1"/>
+          <p:nvPr/>
+        </p:nvSpPr>
+        <p:spPr>
+          <a:xfrm>
+            <a:off x="1097280" y="5486400"/>
+            <a:ext cx="9966960" cy="457200"/>
+          </a:xfrm>
+          <a:prstGeom prst="rect">
+            <a:avLst/>
+          </a:prstGeom>
+          <a:noFill/>
+        </p:spPr>
+        <p:txBody>
+          <a:bodyPr wrap="square">
+            <a:spAutoFit/>
+          </a:bodyPr>
+          <a:lstStyle/>
+          <a:p>
+            <a:pPr algn="l">
+              <a:defRPr sz="1300" b="0" i="1">
+                <a:solidFill>
+                  <a:srgbClr val="8F95A3"/>
+                </a:solidFill>
+                <a:latin typeface="Calibri"/>
+              </a:defRPr>
+            </a:pPr>
+            <a:r>
+              <a:t>💬 "Advanced security measures are paying off with real business impact"</a:t>
             </a:r>
           </a:p>
         </p:txBody>
@@ -4231,7 +4302,7 @@
             <a:avLst/>
           </a:prstGeom>
           <a:solidFill>
-            <a:srgbClr val="7C3AED"/>
+            <a:srgbClr val="059669"/>
           </a:solidFill>
           <a:ln>
             <a:noFill/>
@@ -4284,13 +4355,13 @@
             <a:pPr algn="l">
               <a:defRPr sz="1000" b="1">
                 <a:solidFill>
-                  <a:srgbClr val="7C3AED"/>
-                </a:solidFill>
-                <a:latin typeface="Calibri"/>
-              </a:defRPr>
-            </a:pPr>
-            <a:r>
-              <a:t>🎯  MILESTONE</a:t>
+                  <a:srgbClr val="059669"/>
+                </a:solidFill>
+                <a:latin typeface="Calibri"/>
+              </a:defRPr>
+            </a:pPr>
+            <a:r>
+              <a:t>🎮  WIN</a:t>
             </a:r>
           </a:p>
         </p:txBody>
@@ -4320,13 +4391,13 @@
             <a:pPr algn="l">
               <a:defRPr sz="3200" b="1" i="0">
                 <a:solidFill>
-                  <a:srgbClr val="7C3AED"/>
-                </a:solidFill>
-                <a:latin typeface="Calibri"/>
-              </a:defRPr>
-            </a:pPr>
-            <a:r>
-              <a:t>Vision 2030</a:t>
+                  <a:srgbClr val="059669"/>
+                </a:solidFill>
+                <a:latin typeface="Calibri"/>
+              </a:defRPr>
+            </a:pPr>
+            <a:r>
+              <a:t>Gaming Profitability</a:t>
             </a:r>
           </a:p>
         </p:txBody>
@@ -4354,15 +4425,15 @@
           <a:lstStyle/>
           <a:p>
             <a:pPr algn="l">
-              <a:defRPr sz="5200" b="1" i="0">
-                <a:solidFill>
-                  <a:srgbClr val="7C3AED"/>
-                </a:solidFill>
-                <a:latin typeface="Calibri"/>
-              </a:defRPr>
-            </a:pPr>
-            <a:r>
-              <a:t>$50B</a:t>
+              <a:defRPr sz="4800" b="1" i="0">
+                <a:solidFill>
+                  <a:srgbClr val="059669"/>
+                </a:solidFill>
+                <a:latin typeface="Calibri"/>
+              </a:defRPr>
+            </a:pPr>
+            <a:r>
+              <a:t>2025</a:t>
             </a:r>
           </a:p>
         </p:txBody>
@@ -4375,7 +4446,7 @@
         </p:nvSpPr>
         <p:spPr>
           <a:xfrm>
-            <a:off x="1097280" y="2926080"/>
+            <a:off x="1097280" y="2834640"/>
             <a:ext cx="4572000" cy="365760"/>
           </a:xfrm>
           <a:prstGeom prst="rect">
@@ -4390,7 +4461,7 @@
           <a:lstStyle/>
           <a:p>
             <a:pPr algn="l">
-              <a:defRPr sz="1100" b="0" i="0">
+              <a:defRPr sz="1200" b="0" i="0">
                 <a:solidFill>
                   <a:srgbClr val="8F95A3"/>
                 </a:solidFill>
@@ -4398,7 +4469,7 @@
               </a:defRPr>
             </a:pPr>
             <a:r>
-              <a:t>Target Valuation</a:t>
+              <a:t>Profitable Year</a:t>
             </a:r>
           </a:p>
         </p:txBody>
@@ -4411,7 +4482,43 @@
         </p:nvSpPr>
         <p:spPr>
           <a:xfrm>
-            <a:off x="1097280" y="3566160"/>
+            <a:off x="1097280" y="3291840"/>
+            <a:ext cx="9966960" cy="365760"/>
+          </a:xfrm>
+          <a:prstGeom prst="rect">
+            <a:avLst/>
+          </a:prstGeom>
+          <a:noFill/>
+        </p:spPr>
+        <p:txBody>
+          <a:bodyPr wrap="square">
+            <a:spAutoFit/>
+          </a:bodyPr>
+          <a:lstStyle/>
+          <a:p>
+            <a:pPr algn="l">
+              <a:defRPr sz="1400" b="0" i="0">
+                <a:solidFill>
+                  <a:srgbClr val="E2E2EA"/>
+                </a:solidFill>
+                <a:latin typeface="Calibri"/>
+              </a:defRPr>
+            </a:pPr>
+            <a:r>
+              <a:t>by Gaming Division</a:t>
+            </a:r>
+          </a:p>
+        </p:txBody>
+      </p:sp>
+      <p:sp>
+        <p:nvSpPr>
+          <p:cNvPr id="8" name="TextBox 7"/>
+          <p:cNvSpPr txBox="1"/>
+          <p:nvPr/>
+        </p:nvSpPr>
+        <p:spPr>
+          <a:xfrm>
+            <a:off x="1097280" y="3840480"/>
             <a:ext cx="9966960" cy="457200"/>
           </a:xfrm>
           <a:prstGeom prst="rect">
@@ -4434,35 +4541,35 @@
               </a:defRPr>
             </a:pPr>
             <a:r>
-              <a:t>Building Toward Greatness</a:t>
-            </a:r>
-          </a:p>
-        </p:txBody>
-      </p:sp>
-      <p:sp>
-        <p:nvSpPr>
-          <p:cNvPr id="8" name="TextBox 7"/>
-          <p:cNvSpPr txBox="1"/>
-          <p:nvPr/>
-        </p:nvSpPr>
-        <p:spPr>
-          <a:xfrm>
-            <a:off x="1097280" y="4206240"/>
-            <a:ext cx="9966960" cy="1371600"/>
-          </a:xfrm>
-          <a:prstGeom prst="rect">
-            <a:avLst/>
-          </a:prstGeom>
-          <a:noFill/>
-        </p:spPr>
-        <p:txBody>
-          <a:bodyPr wrap="square">
-            <a:spAutoFit/>
-          </a:bodyPr>
-          <a:lstStyle/>
-          <a:p>
-            <a:pPr algn="l">
-              <a:defRPr sz="1500" b="0" i="0">
+              <a:t>Gaming division reaches profitability</a:t>
+            </a:r>
+          </a:p>
+        </p:txBody>
+      </p:sp>
+      <p:sp>
+        <p:nvSpPr>
+          <p:cNvPr id="9" name="TextBox 8"/>
+          <p:cNvSpPr txBox="1"/>
+          <p:nvPr/>
+        </p:nvSpPr>
+        <p:spPr>
+          <a:xfrm>
+            <a:off x="1097280" y="4389120"/>
+            <a:ext cx="9966960" cy="914400"/>
+          </a:xfrm>
+          <a:prstGeom prst="rect">
+            <a:avLst/>
+          </a:prstGeom>
+          <a:noFill/>
+        </p:spPr>
+        <p:txBody>
+          <a:bodyPr wrap="square">
+            <a:spAutoFit/>
+          </a:bodyPr>
+          <a:lstStyle/>
+          <a:p>
+            <a:pPr algn="l">
+              <a:defRPr sz="1400" b="0" i="0">
                 <a:solidFill>
                   <a:srgbClr val="E2E2EA"/>
                 </a:solidFill>
@@ -4470,7 +4577,43 @@
               </a:defRPr>
             </a:pPr>
             <a:r>
-              <a:t>Strategic roadmap targeting $50B company valuation with 1,500 employees across 100 studios</a:t>
+              <a:t>Our gaming portfolio has turned the corner, with strong retention rates and optimized monetization strategies driving sustainable profits.</a:t>
+            </a:r>
+          </a:p>
+        </p:txBody>
+      </p:sp>
+      <p:sp>
+        <p:nvSpPr>
+          <p:cNvPr id="10" name="TextBox 9"/>
+          <p:cNvSpPr txBox="1"/>
+          <p:nvPr/>
+        </p:nvSpPr>
+        <p:spPr>
+          <a:xfrm>
+            <a:off x="1097280" y="5486400"/>
+            <a:ext cx="9966960" cy="457200"/>
+          </a:xfrm>
+          <a:prstGeom prst="rect">
+            <a:avLst/>
+          </a:prstGeom>
+          <a:noFill/>
+        </p:spPr>
+        <p:txBody>
+          <a:bodyPr wrap="square">
+            <a:spAutoFit/>
+          </a:bodyPr>
+          <a:lstStyle/>
+          <a:p>
+            <a:pPr algn="l">
+              <a:defRPr sz="1300" b="0" i="1">
+                <a:solidFill>
+                  <a:srgbClr val="8F95A3"/>
+                </a:solidFill>
+                <a:latin typeface="Calibri"/>
+              </a:defRPr>
+            </a:pPr>
+            <a:r>
+              <a:t>💬 "Long-term investments in gaming are now delivering results"</a:t>
             </a:r>
           </a:p>
         </p:txBody>
@@ -4516,7 +4659,7 @@
             <a:avLst/>
           </a:prstGeom>
           <a:solidFill>
-            <a:srgbClr val="06B6D4"/>
+            <a:srgbClr val="EA580C"/>
           </a:solidFill>
           <a:ln>
             <a:noFill/>
@@ -4569,13 +4712,13 @@
             <a:pPr algn="l">
               <a:defRPr sz="1000" b="1">
                 <a:solidFill>
-                  <a:srgbClr val="06B6D4"/>
-                </a:solidFill>
-                <a:latin typeface="Calibri"/>
-              </a:defRPr>
-            </a:pPr>
-            <a:r>
-              <a:t>🤖  WIN</a:t>
+                  <a:srgbClr val="EA580C"/>
+                </a:solidFill>
+                <a:latin typeface="Calibri"/>
+              </a:defRPr>
+            </a:pPr>
+            <a:r>
+              <a:t>📊  WIN</a:t>
             </a:r>
           </a:p>
         </p:txBody>
@@ -4605,13 +4748,13 @@
             <a:pPr algn="l">
               <a:defRPr sz="3200" b="1" i="0">
                 <a:solidFill>
-                  <a:srgbClr val="06B6D4"/>
-                </a:solidFill>
-                <a:latin typeface="Calibri"/>
-              </a:defRPr>
-            </a:pPr>
-            <a:r>
-              <a:t>AI Revolution</a:t>
+                  <a:srgbClr val="EA580C"/>
+                </a:solidFill>
+                <a:latin typeface="Calibri"/>
+              </a:defRPr>
+            </a:pPr>
+            <a:r>
+              <a:t>Crossword ROAS Success</a:t>
             </a:r>
           </a:p>
         </p:txBody>
@@ -4641,13 +4784,13 @@
             <a:pPr algn="l">
               <a:defRPr sz="4800" b="1" i="0">
                 <a:solidFill>
-                  <a:srgbClr val="06B6D4"/>
-                </a:solidFill>
-                <a:latin typeface="Calibri"/>
-              </a:defRPr>
-            </a:pPr>
-            <a:r>
-              <a:t>5-10</a:t>
+                  <a:srgbClr val="EA580C"/>
+                </a:solidFill>
+                <a:latin typeface="Calibri"/>
+              </a:defRPr>
+            </a:pPr>
+            <a:r>
+              <a:t>200%+</a:t>
             </a:r>
           </a:p>
         </p:txBody>
@@ -4683,7 +4826,7 @@
               </a:defRPr>
             </a:pPr>
             <a:r>
-              <a:t>AI Agents per Person</a:t>
+              <a:t>ROAS Exceeded</a:t>
             </a:r>
           </a:p>
         </p:txBody>
@@ -4719,7 +4862,7 @@
               </a:defRPr>
             </a:pPr>
             <a:r>
-              <a:t>by Every Employee</a:t>
+              <a:t>by Marketing Team</a:t>
             </a:r>
           </a:p>
         </p:txBody>
@@ -4755,7 +4898,7 @@
               </a:defRPr>
             </a:pPr>
             <a:r>
-              <a:t>The Future is Now</a:t>
+              <a:t>Crossword campaigns deliver exceptional returns</a:t>
             </a:r>
           </a:p>
         </p:txBody>
@@ -4791,7 +4934,7 @@
               </a:defRPr>
             </a:pPr>
             <a:r>
-              <a:t>Within 3-6 months, every team member will manage 5-10 AI agents, revolutionizing how we work and scale.</a:t>
+              <a:t>Our crossword game marketing has achieved outstanding ROAS above 200%, proving our user acquisition strategies are highly effective.</a:t>
             </a:r>
           </a:p>
         </p:txBody>
@@ -4827,7 +4970,7 @@
               </a:defRPr>
             </a:pPr>
             <a:r>
-              <a:t>💬 "AI isn't replacing us—it's amplifying our capabilities"</a:t>
+              <a:t>💬 "Data-driven marketing is generating impressive returns on investment"</a:t>
             </a:r>
           </a:p>
         </p:txBody>
@@ -4873,7 +5016,7 @@
             <a:avLst/>
           </a:prstGeom>
           <a:solidFill>
-            <a:srgbClr val="F59E0B"/>
+            <a:srgbClr val="8B5CF6"/>
           </a:solidFill>
           <a:ln>
             <a:noFill/>
@@ -4926,13 +5069,13 @@
             <a:pPr algn="l">
               <a:defRPr sz="1000" b="1">
                 <a:solidFill>
-                  <a:srgbClr val="F59E0B"/>
-                </a:solidFill>
-                <a:latin typeface="Calibri"/>
-              </a:defRPr>
-            </a:pPr>
-            <a:r>
-              <a:t>🎮  WIN</a:t>
+                  <a:srgbClr val="8B5CF6"/>
+                </a:solidFill>
+                <a:latin typeface="Calibri"/>
+              </a:defRPr>
+            </a:pPr>
+            <a:r>
+              <a:t>🧘‍♀️  WEEKLY RITUAL</a:t>
             </a:r>
           </a:p>
         </p:txBody>
@@ -4962,13 +5105,13 @@
             <a:pPr algn="l">
               <a:defRPr sz="3200" b="1" i="0">
                 <a:solidFill>
-                  <a:srgbClr val="F59E0B"/>
-                </a:solidFill>
-                <a:latin typeface="Calibri"/>
-              </a:defRPr>
-            </a:pPr>
-            <a:r>
-              <a:t>Gaming Profitability</a:t>
+                  <a:srgbClr val="8B5CF6"/>
+                </a:solidFill>
+                <a:latin typeface="Calibri"/>
+              </a:defRPr>
+            </a:pPr>
+            <a:r>
+              <a:t>Daily Wellness</a:t>
             </a:r>
           </a:p>
         </p:txBody>
@@ -4982,29 +5125,29 @@
         <p:spPr>
           <a:xfrm>
             <a:off x="1097280" y="2103120"/>
-            <a:ext cx="4572000" cy="822960"/>
-          </a:xfrm>
-          <a:prstGeom prst="rect">
-            <a:avLst/>
-          </a:prstGeom>
-          <a:noFill/>
-        </p:spPr>
-        <p:txBody>
-          <a:bodyPr wrap="square">
-            <a:spAutoFit/>
-          </a:bodyPr>
-          <a:lstStyle/>
-          <a:p>
-            <a:pPr algn="l">
-              <a:defRPr sz="4800" b="1" i="0">
-                <a:solidFill>
-                  <a:srgbClr val="F59E0B"/>
-                </a:solidFill>
-                <a:latin typeface="Calibri"/>
-              </a:defRPr>
-            </a:pPr>
-            <a:r>
-              <a:t>61%</a:t>
+            <a:ext cx="9966960" cy="457200"/>
+          </a:xfrm>
+          <a:prstGeom prst="rect">
+            <a:avLst/>
+          </a:prstGeom>
+          <a:noFill/>
+        </p:spPr>
+        <p:txBody>
+          <a:bodyPr wrap="square">
+            <a:spAutoFit/>
+          </a:bodyPr>
+          <a:lstStyle/>
+          <a:p>
+            <a:pPr algn="l">
+              <a:defRPr sz="1800" b="1" i="0">
+                <a:solidFill>
+                  <a:srgbClr val="FFFFFF"/>
+                </a:solidFill>
+                <a:latin typeface="Calibri"/>
+              </a:defRPr>
+            </a:pPr>
+            <a:r>
+              <a:t>Daily yoga brings balance to our workday</a:t>
             </a:r>
           </a:p>
         </p:txBody>
@@ -5017,30 +5160,30 @@
         </p:nvSpPr>
         <p:spPr>
           <a:xfrm>
-            <a:off x="1097280" y="2834640"/>
-            <a:ext cx="4572000" cy="365760"/>
-          </a:xfrm>
-          <a:prstGeom prst="rect">
-            <a:avLst/>
-          </a:prstGeom>
-          <a:noFill/>
-        </p:spPr>
-        <p:txBody>
-          <a:bodyPr wrap="square">
-            <a:spAutoFit/>
-          </a:bodyPr>
-          <a:lstStyle/>
-          <a:p>
-            <a:pPr algn="l">
-              <a:defRPr sz="1200" b="0" i="0">
-                <a:solidFill>
-                  <a:srgbClr val="8F95A3"/>
-                </a:solidFill>
-                <a:latin typeface="Calibri"/>
-              </a:defRPr>
-            </a:pPr>
-            <a:r>
-              <a:t>Retention Rate</a:t>
+            <a:off x="1371600" y="2926080"/>
+            <a:ext cx="9418320" cy="548640"/>
+          </a:xfrm>
+          <a:prstGeom prst="rect">
+            <a:avLst/>
+          </a:prstGeom>
+          <a:noFill/>
+        </p:spPr>
+        <p:txBody>
+          <a:bodyPr wrap="square">
+            <a:spAutoFit/>
+          </a:bodyPr>
+          <a:lstStyle/>
+          <a:p>
+            <a:pPr algn="l">
+              <a:defRPr sz="1400" b="0" i="0">
+                <a:solidFill>
+                  <a:srgbClr val="E2E2EA"/>
+                </a:solidFill>
+                <a:latin typeface="Calibri"/>
+              </a:defRPr>
+            </a:pPr>
+            <a:r>
+              <a:t>How has yoga helped you?</a:t>
             </a:r>
           </a:p>
         </p:txBody>
@@ -5053,8 +5196,8 @@
         </p:nvSpPr>
         <p:spPr>
           <a:xfrm>
-            <a:off x="1097280" y="3291840"/>
-            <a:ext cx="9966960" cy="365760"/>
+            <a:off x="1371600" y="3657600"/>
+            <a:ext cx="9418320" cy="548640"/>
           </a:xfrm>
           <a:prstGeom prst="rect">
             <a:avLst/>
@@ -5076,7 +5219,7 @@
               </a:defRPr>
             </a:pPr>
             <a:r>
-              <a:t>by Gaming Division</a:t>
+              <a:t>What wellness practices work for you?</a:t>
             </a:r>
           </a:p>
         </p:txBody>
@@ -5089,30 +5232,30 @@
         </p:nvSpPr>
         <p:spPr>
           <a:xfrm>
-            <a:off x="1097280" y="3840480"/>
-            <a:ext cx="9966960" cy="457200"/>
-          </a:xfrm>
-          <a:prstGeom prst="rect">
-            <a:avLst/>
-          </a:prstGeom>
-          <a:noFill/>
-        </p:spPr>
-        <p:txBody>
-          <a:bodyPr wrap="square">
-            <a:spAutoFit/>
-          </a:bodyPr>
-          <a:lstStyle/>
-          <a:p>
-            <a:pPr algn="l">
-              <a:defRPr sz="1800" b="1" i="0">
-                <a:solidFill>
-                  <a:srgbClr val="FFFFFF"/>
-                </a:solidFill>
-                <a:latin typeface="Calibri"/>
-              </a:defRPr>
-            </a:pPr>
-            <a:r>
-              <a:t>Gaming Turned Profitable in 2025</a:t>
+            <a:off x="1097280" y="4754880"/>
+            <a:ext cx="9966960" cy="731520"/>
+          </a:xfrm>
+          <a:prstGeom prst="rect">
+            <a:avLst/>
+          </a:prstGeom>
+          <a:noFill/>
+        </p:spPr>
+        <p:txBody>
+          <a:bodyPr wrap="square">
+            <a:spAutoFit/>
+          </a:bodyPr>
+          <a:lstStyle/>
+          <a:p>
+            <a:pPr algn="l">
+              <a:defRPr sz="1500" b="0" i="1">
+                <a:solidFill>
+                  <a:srgbClr val="E2E2EA"/>
+                </a:solidFill>
+                <a:latin typeface="Calibri"/>
+              </a:defRPr>
+            </a:pPr>
+            <a:r>
+              <a:t>We care for our people's wellbeing</a:t>
             </a:r>
           </a:p>
         </p:txBody>
@@ -5125,66 +5268,30 @@
         </p:nvSpPr>
         <p:spPr>
           <a:xfrm>
-            <a:off x="1097280" y="4389120"/>
-            <a:ext cx="9966960" cy="914400"/>
-          </a:xfrm>
-          <a:prstGeom prst="rect">
-            <a:avLst/>
-          </a:prstGeom>
-          <a:noFill/>
-        </p:spPr>
-        <p:txBody>
-          <a:bodyPr wrap="square">
-            <a:spAutoFit/>
-          </a:bodyPr>
-          <a:lstStyle/>
-          <a:p>
-            <a:pPr algn="l">
-              <a:defRPr sz="1400" b="0" i="0">
-                <a:solidFill>
-                  <a:srgbClr val="E2E2EA"/>
-                </a:solidFill>
-                <a:latin typeface="Calibri"/>
-              </a:defRPr>
-            </a:pPr>
-            <a:r>
-              <a:t>Infinite Minesweeper achieving 61% retention, with Solitaire v540 boosting D7 retention by +21.67%</a:t>
-            </a:r>
-          </a:p>
-        </p:txBody>
-      </p:sp>
-      <p:sp>
-        <p:nvSpPr>
-          <p:cNvPr id="10" name="TextBox 9"/>
-          <p:cNvSpPr txBox="1"/>
-          <p:nvPr/>
-        </p:nvSpPr>
-        <p:spPr>
-          <a:xfrm>
-            <a:off x="1097280" y="5486400"/>
-            <a:ext cx="9966960" cy="457200"/>
-          </a:xfrm>
-          <a:prstGeom prst="rect">
-            <a:avLst/>
-          </a:prstGeom>
-          <a:noFill/>
-        </p:spPr>
-        <p:txBody>
-          <a:bodyPr wrap="square">
-            <a:spAutoFit/>
-          </a:bodyPr>
-          <a:lstStyle/>
-          <a:p>
-            <a:pPr algn="l">
-              <a:defRPr sz="1300" b="0" i="1">
-                <a:solidFill>
-                  <a:srgbClr val="8F95A3"/>
-                </a:solidFill>
-                <a:latin typeface="Calibri"/>
-              </a:defRPr>
-            </a:pPr>
-            <a:r>
-              <a:t>💬 "Strategic pivot to gaming is paying off massively"</a:t>
+            <a:off x="1097280" y="5760720"/>
+            <a:ext cx="9966960" cy="274320"/>
+          </a:xfrm>
+          <a:prstGeom prst="rect">
+            <a:avLst/>
+          </a:prstGeom>
+          <a:noFill/>
+        </p:spPr>
+        <p:txBody>
+          <a:bodyPr wrap="square">
+            <a:spAutoFit/>
+          </a:bodyPr>
+          <a:lstStyle/>
+          <a:p>
+            <a:pPr algn="l">
+              <a:defRPr sz="1100" b="0" i="0">
+                <a:solidFill>
+                  <a:srgbClr val="5C6270"/>
+                </a:solidFill>
+                <a:latin typeface="Calibri"/>
+              </a:defRPr>
+            </a:pPr>
+            <a:r>
+              <a:t>Office &amp; Online at 13:10 CET</a:t>
             </a:r>
           </a:p>
         </p:txBody>
@@ -5230,7 +5337,7 @@
             <a:avLst/>
           </a:prstGeom>
           <a:solidFill>
-            <a:srgbClr val="EF4444"/>
+            <a:srgbClr val="0891B2"/>
           </a:solidFill>
           <a:ln>
             <a:noFill/>
@@ -5283,13 +5390,13 @@
             <a:pPr algn="l">
               <a:defRPr sz="1000" b="1">
                 <a:solidFill>
-                  <a:srgbClr val="EF4444"/>
-                </a:solidFill>
-                <a:latin typeface="Calibri"/>
-              </a:defRPr>
-            </a:pPr>
-            <a:r>
-              <a:t>🛡️  WIN</a:t>
+                  <a:srgbClr val="0891B2"/>
+                </a:solidFill>
+                <a:latin typeface="Calibri"/>
+              </a:defRPr>
+            </a:pPr>
+            <a:r>
+              <a:t>📚  EVENT</a:t>
             </a:r>
           </a:p>
         </p:txBody>
@@ -5319,13 +5426,13 @@
             <a:pPr algn="l">
               <a:defRPr sz="3200" b="1" i="0">
                 <a:solidFill>
-                  <a:srgbClr val="EF4444"/>
-                </a:solidFill>
-                <a:latin typeface="Calibri"/>
-              </a:defRPr>
-            </a:pPr>
-            <a:r>
-              <a:t>Fraud Prevention Victory</a:t>
+                  <a:srgbClr val="0891B2"/>
+                </a:solidFill>
+                <a:latin typeface="Calibri"/>
+              </a:defRPr>
+            </a:pPr>
+            <a:r>
+              <a:t>Book Club Growing</a:t>
             </a:r>
           </a:p>
         </p:txBody>
@@ -5339,29 +5446,29 @@
         <p:spPr>
           <a:xfrm>
             <a:off x="1097280" y="2103120"/>
-            <a:ext cx="4572000" cy="822960"/>
-          </a:xfrm>
-          <a:prstGeom prst="rect">
-            <a:avLst/>
-          </a:prstGeom>
-          <a:noFill/>
-        </p:spPr>
-        <p:txBody>
-          <a:bodyPr wrap="square">
-            <a:spAutoFit/>
-          </a:bodyPr>
-          <a:lstStyle/>
-          <a:p>
-            <a:pPr algn="l">
-              <a:defRPr sz="4800" b="1" i="0">
-                <a:solidFill>
-                  <a:srgbClr val="EF4444"/>
-                </a:solidFill>
-                <a:latin typeface="Calibri"/>
-              </a:defRPr>
-            </a:pPr>
-            <a:r>
-              <a:t>82%</a:t>
+            <a:ext cx="9966960" cy="548640"/>
+          </a:xfrm>
+          <a:prstGeom prst="rect">
+            <a:avLst/>
+          </a:prstGeom>
+          <a:noFill/>
+        </p:spPr>
+        <p:txBody>
+          <a:bodyPr wrap="square">
+            <a:spAutoFit/>
+          </a:bodyPr>
+          <a:lstStyle/>
+          <a:p>
+            <a:pPr algn="l">
+              <a:defRPr sz="2200" b="1" i="0">
+                <a:solidFill>
+                  <a:srgbClr val="FFFFFF"/>
+                </a:solidFill>
+                <a:latin typeface="Calibri"/>
+              </a:defRPr>
+            </a:pPr>
+            <a:r>
+              <a:t>Passionate Curiosity Book Club</a:t>
             </a:r>
           </a:p>
         </p:txBody>
@@ -5374,22 +5481,94 @@
         </p:nvSpPr>
         <p:spPr>
           <a:xfrm>
-            <a:off x="1097280" y="2834640"/>
-            <a:ext cx="4572000" cy="365760"/>
-          </a:xfrm>
-          <a:prstGeom prst="rect">
-            <a:avLst/>
-          </a:prstGeom>
-          <a:noFill/>
-        </p:spPr>
-        <p:txBody>
-          <a:bodyPr wrap="square">
-            <a:spAutoFit/>
-          </a:bodyPr>
-          <a:lstStyle/>
-          <a:p>
-            <a:pPr algn="l">
-              <a:defRPr sz="1200" b="0" i="0">
+            <a:off x="1097280" y="2743200"/>
+            <a:ext cx="9966960" cy="365760"/>
+          </a:xfrm>
+          <a:prstGeom prst="rect">
+            <a:avLst/>
+          </a:prstGeom>
+          <a:noFill/>
+        </p:spPr>
+        <p:txBody>
+          <a:bodyPr wrap="square">
+            <a:spAutoFit/>
+          </a:bodyPr>
+          <a:lstStyle/>
+          <a:p>
+            <a:pPr algn="l">
+              <a:defRPr sz="1400" b="1" i="0">
+                <a:solidFill>
+                  <a:srgbClr val="0891B2"/>
+                </a:solidFill>
+                <a:latin typeface="Calibri"/>
+              </a:defRPr>
+            </a:pPr>
+            <a:r>
+              <a:t>Ongoing</a:t>
+            </a:r>
+          </a:p>
+        </p:txBody>
+      </p:sp>
+      <p:sp>
+        <p:nvSpPr>
+          <p:cNvPr id="7" name="TextBox 6"/>
+          <p:cNvSpPr txBox="1"/>
+          <p:nvPr/>
+        </p:nvSpPr>
+        <p:spPr>
+          <a:xfrm>
+            <a:off x="1097280" y="3291840"/>
+            <a:ext cx="9966960" cy="1371600"/>
+          </a:xfrm>
+          <a:prstGeom prst="rect">
+            <a:avLst/>
+          </a:prstGeom>
+          <a:noFill/>
+        </p:spPr>
+        <p:txBody>
+          <a:bodyPr wrap="square">
+            <a:spAutoFit/>
+          </a:bodyPr>
+          <a:lstStyle/>
+          <a:p>
+            <a:pPr algn="l">
+              <a:defRPr sz="1500" b="0" i="0">
+                <a:solidFill>
+                  <a:srgbClr val="E2E2EA"/>
+                </a:solidFill>
+                <a:latin typeface="Calibri"/>
+              </a:defRPr>
+            </a:pPr>
+            <a:r>
+              <a:t>Our book club has grown to 140+ participants, fostering a culture of continuous learning and intellectual curiosity across the company.</a:t>
+            </a:r>
+          </a:p>
+        </p:txBody>
+      </p:sp>
+      <p:sp>
+        <p:nvSpPr>
+          <p:cNvPr id="8" name="TextBox 7"/>
+          <p:cNvSpPr txBox="1"/>
+          <p:nvPr/>
+        </p:nvSpPr>
+        <p:spPr>
+          <a:xfrm>
+            <a:off x="1097280" y="5029200"/>
+            <a:ext cx="9966960" cy="365760"/>
+          </a:xfrm>
+          <a:prstGeom prst="rect">
+            <a:avLst/>
+          </a:prstGeom>
+          <a:noFill/>
+        </p:spPr>
+        <p:txBody>
+          <a:bodyPr wrap="square">
+            <a:spAutoFit/>
+          </a:bodyPr>
+          <a:lstStyle/>
+          <a:p>
+            <a:pPr algn="l">
+              <a:defRPr sz="1300" b="0" i="0">
                 <a:solidFill>
                   <a:srgbClr val="8F95A3"/>
                 </a:solidFill>
@@ -5397,472 +5576,7 @@
               </a:defRPr>
             </a:pPr>
             <a:r>
-              <a:t>Fraud Reduction</a:t>
-            </a:r>
-          </a:p>
-        </p:txBody>
-      </p:sp>
-      <p:sp>
-        <p:nvSpPr>
-          <p:cNvPr id="7" name="TextBox 6"/>
-          <p:cNvSpPr txBox="1"/>
-          <p:nvPr/>
-        </p:nvSpPr>
-        <p:spPr>
-          <a:xfrm>
-            <a:off x="1097280" y="3291840"/>
-            <a:ext cx="9966960" cy="365760"/>
-          </a:xfrm>
-          <a:prstGeom prst="rect">
-            <a:avLst/>
-          </a:prstGeom>
-          <a:noFill/>
-        </p:spPr>
-        <p:txBody>
-          <a:bodyPr wrap="square">
-            <a:spAutoFit/>
-          </a:bodyPr>
-          <a:lstStyle/>
-          <a:p>
-            <a:pPr algn="l">
-              <a:defRPr sz="1400" b="0" i="0">
-                <a:solidFill>
-                  <a:srgbClr val="E2E2EA"/>
-                </a:solidFill>
-                <a:latin typeface="Calibri"/>
-              </a:defRPr>
-            </a:pPr>
-            <a:r>
-              <a:t>by Security Team</a:t>
-            </a:r>
-          </a:p>
-        </p:txBody>
-      </p:sp>
-      <p:sp>
-        <p:nvSpPr>
-          <p:cNvPr id="8" name="TextBox 7"/>
-          <p:cNvSpPr txBox="1"/>
-          <p:nvPr/>
-        </p:nvSpPr>
-        <p:spPr>
-          <a:xfrm>
-            <a:off x="1097280" y="3840480"/>
-            <a:ext cx="9966960" cy="457200"/>
-          </a:xfrm>
-          <a:prstGeom prst="rect">
-            <a:avLst/>
-          </a:prstGeom>
-          <a:noFill/>
-        </p:spPr>
-        <p:txBody>
-          <a:bodyPr wrap="square">
-            <a:spAutoFit/>
-          </a:bodyPr>
-          <a:lstStyle/>
-          <a:p>
-            <a:pPr algn="l">
-              <a:defRPr sz="1800" b="1" i="0">
-                <a:solidFill>
-                  <a:srgbClr val="FFFFFF"/>
-                </a:solidFill>
-                <a:latin typeface="Calibri"/>
-              </a:defRPr>
-            </a:pPr>
-            <a:r>
-              <a:t>From 22% to Under 4% Fraud</a:t>
-            </a:r>
-          </a:p>
-        </p:txBody>
-      </p:sp>
-      <p:sp>
-        <p:nvSpPr>
-          <p:cNvPr id="9" name="TextBox 8"/>
-          <p:cNvSpPr txBox="1"/>
-          <p:nvPr/>
-        </p:nvSpPr>
-        <p:spPr>
-          <a:xfrm>
-            <a:off x="1097280" y="4389120"/>
-            <a:ext cx="9966960" cy="914400"/>
-          </a:xfrm>
-          <a:prstGeom prst="rect">
-            <a:avLst/>
-          </a:prstGeom>
-          <a:noFill/>
-        </p:spPr>
-        <p:txBody>
-          <a:bodyPr wrap="square">
-            <a:spAutoFit/>
-          </a:bodyPr>
-          <a:lstStyle/>
-          <a:p>
-            <a:pPr algn="l">
-              <a:defRPr sz="1400" b="0" i="0">
-                <a:solidFill>
-                  <a:srgbClr val="E2E2EA"/>
-                </a:solidFill>
-                <a:latin typeface="Calibri"/>
-              </a:defRPr>
-            </a:pPr>
-            <a:r>
-              <a:t>Dynamic SDK signatures slashed fraud rates dramatically, protecting revenue and user experience</a:t>
-            </a:r>
-          </a:p>
-        </p:txBody>
-      </p:sp>
-      <p:sp>
-        <p:nvSpPr>
-          <p:cNvPr id="10" name="TextBox 9"/>
-          <p:cNvSpPr txBox="1"/>
-          <p:nvPr/>
-        </p:nvSpPr>
-        <p:spPr>
-          <a:xfrm>
-            <a:off x="1097280" y="5486400"/>
-            <a:ext cx="9966960" cy="457200"/>
-          </a:xfrm>
-          <a:prstGeom prst="rect">
-            <a:avLst/>
-          </a:prstGeom>
-          <a:noFill/>
-        </p:spPr>
-        <p:txBody>
-          <a:bodyPr wrap="square">
-            <a:spAutoFit/>
-          </a:bodyPr>
-          <a:lstStyle/>
-          <a:p>
-            <a:pPr algn="l">
-              <a:defRPr sz="1300" b="0" i="1">
-                <a:solidFill>
-                  <a:srgbClr val="8F95A3"/>
-                </a:solidFill>
-                <a:latin typeface="Calibri"/>
-              </a:defRPr>
-            </a:pPr>
-            <a:r>
-              <a:t>💬 "Innovation in security drives business results"</a:t>
-            </a:r>
-          </a:p>
-        </p:txBody>
-      </p:sp>
-    </p:spTree>
-  </p:cSld>
-  <p:clrMapOvr>
-    <a:masterClrMapping/>
-  </p:clrMapOvr>
-</p:sld>
-</file>
-
-<file path=ppt/slides/slide17.xml><?xml version="1.0" encoding="utf-8"?>
-<p:sld xmlns:a="http://schemas.openxmlformats.org/drawingml/2006/main" xmlns:p="http://schemas.openxmlformats.org/presentationml/2006/main" xmlns:r="http://schemas.openxmlformats.org/officeDocument/2006/relationships">
-  <p:cSld>
-    <p:bg>
-      <p:bgPr>
-        <a:solidFill>
-          <a:srgbClr val="08080C"/>
-        </a:solidFill>
-        <a:effectLst/>
-      </p:bgPr>
-    </p:bg>
-    <p:spTree>
-      <p:nvGrpSpPr>
-        <p:cNvPr id="1" name=""/>
-        <p:cNvGrpSpPr/>
-        <p:nvPr/>
-      </p:nvGrpSpPr>
-      <p:grpSpPr/>
-      <p:sp>
-        <p:nvSpPr>
-          <p:cNvPr id="2" name="Rectangle 1"/>
-          <p:cNvSpPr/>
-          <p:nvPr/>
-        </p:nvSpPr>
-        <p:spPr>
-          <a:xfrm>
-            <a:off x="0" y="365760"/>
-            <a:ext cx="12191695" cy="54864"/>
-          </a:xfrm>
-          <a:prstGeom prst="rect">
-            <a:avLst/>
-          </a:prstGeom>
-          <a:solidFill>
-            <a:srgbClr val="8B5CF6"/>
-          </a:solidFill>
-          <a:ln>
-            <a:noFill/>
-          </a:ln>
-        </p:spPr>
-        <p:style>
-          <a:lnRef idx="1">
-            <a:schemeClr val="accent1"/>
-          </a:lnRef>
-          <a:fillRef idx="3">
-            <a:schemeClr val="accent1"/>
-          </a:fillRef>
-          <a:effectRef idx="2">
-            <a:schemeClr val="accent1"/>
-          </a:effectRef>
-          <a:fontRef idx="minor">
-            <a:schemeClr val="lt1"/>
-          </a:fontRef>
-        </p:style>
-        <p:txBody>
-          <a:bodyPr rtlCol="0" anchor="ctr"/>
-          <a:lstStyle/>
-          <a:p>
-            <a:pPr algn="ctr"/>
-          </a:p>
-        </p:txBody>
-      </p:sp>
-      <p:sp>
-        <p:nvSpPr>
-          <p:cNvPr id="3" name="TextBox 2"/>
-          <p:cNvSpPr txBox="1"/>
-          <p:nvPr/>
-        </p:nvSpPr>
-        <p:spPr>
-          <a:xfrm>
-            <a:off x="1097280" y="731520"/>
-            <a:ext cx="3657600" cy="365760"/>
-          </a:xfrm>
-          <a:prstGeom prst="rect">
-            <a:avLst/>
-          </a:prstGeom>
-          <a:noFill/>
-        </p:spPr>
-        <p:txBody>
-          <a:bodyPr wrap="none">
-            <a:spAutoFit/>
-          </a:bodyPr>
-          <a:lstStyle/>
-          <a:p>
-            <a:pPr algn="l">
-              <a:defRPr sz="1000" b="1">
-                <a:solidFill>
-                  <a:srgbClr val="8B5CF6"/>
-                </a:solidFill>
-                <a:latin typeface="Calibri"/>
-              </a:defRPr>
-            </a:pPr>
-            <a:r>
-              <a:t>📚  WEEKLY RITUAL</a:t>
-            </a:r>
-          </a:p>
-        </p:txBody>
-      </p:sp>
-      <p:sp>
-        <p:nvSpPr>
-          <p:cNvPr id="4" name="TextBox 3"/>
-          <p:cNvSpPr txBox="1"/>
-          <p:nvPr/>
-        </p:nvSpPr>
-        <p:spPr>
-          <a:xfrm>
-            <a:off x="1097280" y="1188720"/>
-            <a:ext cx="9966960" cy="731520"/>
-          </a:xfrm>
-          <a:prstGeom prst="rect">
-            <a:avLst/>
-          </a:prstGeom>
-          <a:noFill/>
-        </p:spPr>
-        <p:txBody>
-          <a:bodyPr wrap="square">
-            <a:spAutoFit/>
-          </a:bodyPr>
-          <a:lstStyle/>
-          <a:p>
-            <a:pPr algn="l">
-              <a:defRPr sz="3200" b="1" i="0">
-                <a:solidFill>
-                  <a:srgbClr val="8B5CF6"/>
-                </a:solidFill>
-                <a:latin typeface="Calibri"/>
-              </a:defRPr>
-            </a:pPr>
-            <a:r>
-              <a:t>Book Club Thriving</a:t>
-            </a:r>
-          </a:p>
-        </p:txBody>
-      </p:sp>
-      <p:sp>
-        <p:nvSpPr>
-          <p:cNvPr id="5" name="TextBox 4"/>
-          <p:cNvSpPr txBox="1"/>
-          <p:nvPr/>
-        </p:nvSpPr>
-        <p:spPr>
-          <a:xfrm>
-            <a:off x="1097280" y="2103120"/>
-            <a:ext cx="9966960" cy="457200"/>
-          </a:xfrm>
-          <a:prstGeom prst="rect">
-            <a:avLst/>
-          </a:prstGeom>
-          <a:noFill/>
-        </p:spPr>
-        <p:txBody>
-          <a:bodyPr wrap="square">
-            <a:spAutoFit/>
-          </a:bodyPr>
-          <a:lstStyle/>
-          <a:p>
-            <a:pPr algn="l">
-              <a:defRPr sz="1800" b="1" i="0">
-                <a:solidFill>
-                  <a:srgbClr val="FFFFFF"/>
-                </a:solidFill>
-                <a:latin typeface="Calibri"/>
-              </a:defRPr>
-            </a:pPr>
-            <a:r>
-              <a:t>Passionate Curiosity Lives Here</a:t>
-            </a:r>
-          </a:p>
-        </p:txBody>
-      </p:sp>
-      <p:sp>
-        <p:nvSpPr>
-          <p:cNvPr id="6" name="TextBox 5"/>
-          <p:cNvSpPr txBox="1"/>
-          <p:nvPr/>
-        </p:nvSpPr>
-        <p:spPr>
-          <a:xfrm>
-            <a:off x="1371600" y="2926080"/>
-            <a:ext cx="9418320" cy="548640"/>
-          </a:xfrm>
-          <a:prstGeom prst="rect">
-            <a:avLst/>
-          </a:prstGeom>
-          <a:noFill/>
-        </p:spPr>
-        <p:txBody>
-          <a:bodyPr wrap="square">
-            <a:spAutoFit/>
-          </a:bodyPr>
-          <a:lstStyle/>
-          <a:p>
-            <a:pPr algn="l">
-              <a:defRPr sz="1400" b="0" i="0">
-                <a:solidFill>
-                  <a:srgbClr val="E2E2EA"/>
-                </a:solidFill>
-                <a:latin typeface="Calibri"/>
-              </a:defRPr>
-            </a:pPr>
-            <a:r>
-              <a:t>Join 140+ colleagues in our Book Club</a:t>
-            </a:r>
-          </a:p>
-        </p:txBody>
-      </p:sp>
-      <p:sp>
-        <p:nvSpPr>
-          <p:cNvPr id="7" name="TextBox 6"/>
-          <p:cNvSpPr txBox="1"/>
-          <p:nvPr/>
-        </p:nvSpPr>
-        <p:spPr>
-          <a:xfrm>
-            <a:off x="1371600" y="3657600"/>
-            <a:ext cx="9418320" cy="548640"/>
-          </a:xfrm>
-          <a:prstGeom prst="rect">
-            <a:avLst/>
-          </a:prstGeom>
-          <a:noFill/>
-        </p:spPr>
-        <p:txBody>
-          <a:bodyPr wrap="square">
-            <a:spAutoFit/>
-          </a:bodyPr>
-          <a:lstStyle/>
-          <a:p>
-            <a:pPr algn="l">
-              <a:defRPr sz="1400" b="0" i="0">
-                <a:solidFill>
-                  <a:srgbClr val="E2E2EA"/>
-                </a:solidFill>
-                <a:latin typeface="Calibri"/>
-              </a:defRPr>
-            </a:pPr>
-            <a:r>
-              <a:t>Building minds and connections together</a:t>
-            </a:r>
-          </a:p>
-        </p:txBody>
-      </p:sp>
-      <p:sp>
-        <p:nvSpPr>
-          <p:cNvPr id="8" name="TextBox 7"/>
-          <p:cNvSpPr txBox="1"/>
-          <p:nvPr/>
-        </p:nvSpPr>
-        <p:spPr>
-          <a:xfrm>
-            <a:off x="1097280" y="4754880"/>
-            <a:ext cx="9966960" cy="731520"/>
-          </a:xfrm>
-          <a:prstGeom prst="rect">
-            <a:avLst/>
-          </a:prstGeom>
-          <a:noFill/>
-        </p:spPr>
-        <p:txBody>
-          <a:bodyPr wrap="square">
-            <a:spAutoFit/>
-          </a:bodyPr>
-          <a:lstStyle/>
-          <a:p>
-            <a:pPr algn="l">
-              <a:defRPr sz="1500" b="0" i="1">
-                <a:solidFill>
-                  <a:srgbClr val="E2E2EA"/>
-                </a:solidFill>
-                <a:latin typeface="Calibri"/>
-              </a:defRPr>
-            </a:pPr>
-            <a:r>
-              <a:t>Continuous Learning</a:t>
-            </a:r>
-          </a:p>
-        </p:txBody>
-      </p:sp>
-      <p:sp>
-        <p:nvSpPr>
-          <p:cNvPr id="9" name="TextBox 8"/>
-          <p:cNvSpPr txBox="1"/>
-          <p:nvPr/>
-        </p:nvSpPr>
-        <p:spPr>
-          <a:xfrm>
-            <a:off x="1097280" y="5760720"/>
-            <a:ext cx="9966960" cy="274320"/>
-          </a:xfrm>
-          <a:prstGeom prst="rect">
-            <a:avLst/>
-          </a:prstGeom>
-          <a:noFill/>
-        </p:spPr>
-        <p:txBody>
-          <a:bodyPr wrap="square">
-            <a:spAutoFit/>
-          </a:bodyPr>
-          <a:lstStyle/>
-          <a:p>
-            <a:pPr algn="l">
-              <a:defRPr sz="1100" b="0" i="0">
-                <a:solidFill>
-                  <a:srgbClr val="5C6270"/>
-                </a:solidFill>
-                <a:latin typeface="Calibri"/>
-              </a:defRPr>
-            </a:pPr>
-            <a:r>
-              <a:t>#book-club</a:t>
+              <a:t>Organized by Learning &amp; Development Team</a:t>
             </a:r>
           </a:p>
         </p:txBody>
@@ -5908,7 +5622,7 @@
             <a:avLst/>
           </a:prstGeom>
           <a:solidFill>
-            <a:srgbClr val="F59E0B"/>
+            <a:srgbClr val="EC4899"/>
           </a:solidFill>
           <a:ln>
             <a:noFill/>
@@ -5961,7 +5675,7 @@
             <a:pPr algn="l">
               <a:defRPr sz="1000" b="1">
                 <a:solidFill>
-                  <a:srgbClr val="F59E0B"/>
+                  <a:srgbClr val="EC4899"/>
                 </a:solidFill>
                 <a:latin typeface="Calibri"/>
               </a:defRPr>
@@ -5997,7 +5711,7 @@
             <a:pPr algn="l">
               <a:defRPr sz="3200" b="1" i="0">
                 <a:solidFill>
-                  <a:srgbClr val="F59E0B"/>
+                  <a:srgbClr val="EC4899"/>
                 </a:solidFill>
                 <a:latin typeface="Calibri"/>
               </a:defRPr>
@@ -6111,7 +5825,7 @@
               </a:defRPr>
             </a:pPr>
             <a:r>
-              <a:t>Thank you for all your explanations and bringing so much value to our team! The whole company is celebrating you today.</a:t>
+              <a:t>Thank you for all your explanations! You bring so much value, energy, and good vibes to our team. May this year be filled with new adventures, bold goals, and plenty of little wins that make you smile along the way.</a:t>
             </a:r>
           </a:p>
         </p:txBody>
@@ -6141,13 +5855,13 @@
             <a:pPr algn="l">
               <a:defRPr sz="1400" b="0" i="1">
                 <a:solidFill>
-                  <a:srgbClr val="F59E0B"/>
-                </a:solidFill>
-                <a:latin typeface="Calibri"/>
-              </a:defRPr>
-            </a:pPr>
-            <a:r>
-              <a:t>Tech Team</a:t>
+                  <a:srgbClr val="EC4899"/>
+                </a:solidFill>
+                <a:latin typeface="Calibri"/>
+              </a:defRPr>
+            </a:pPr>
+            <a:r>
+              <a:t>Celebrated by the entire team</a:t>
             </a:r>
           </a:p>
         </p:txBody>
@@ -6193,7 +5907,7 @@
             <a:avLst/>
           </a:prstGeom>
           <a:solidFill>
-            <a:srgbClr val="EF4444"/>
+            <a:srgbClr val="059669"/>
           </a:solidFill>
           <a:ln>
             <a:noFill/>
@@ -6246,13 +5960,13 @@
             <a:pPr algn="l">
               <a:defRPr sz="1000" b="1">
                 <a:solidFill>
-                  <a:srgbClr val="EF4444"/>
-                </a:solidFill>
-                <a:latin typeface="Calibri"/>
-              </a:defRPr>
-            </a:pPr>
-            <a:r>
-              <a:t>💔  OFFICE LIFE</a:t>
+                  <a:srgbClr val="059669"/>
+                </a:solidFill>
+                <a:latin typeface="Calibri"/>
+              </a:defRPr>
+            </a:pPr>
+            <a:r>
+              <a:t>👏  CLAPS</a:t>
             </a:r>
           </a:p>
         </p:txBody>
@@ -6282,13 +5996,13 @@
             <a:pPr algn="l">
               <a:defRPr sz="3200" b="1" i="0">
                 <a:solidFill>
-                  <a:srgbClr val="EF4444"/>
-                </a:solidFill>
-                <a:latin typeface="Calibri"/>
-              </a:defRPr>
-            </a:pPr>
-            <a:r>
-              <a:t>Supporting Our Team</a:t>
+                  <a:srgbClr val="059669"/>
+                </a:solidFill>
+                <a:latin typeface="Calibri"/>
+              </a:defRPr>
+            </a:pPr>
+            <a:r>
+              <a:t>Top Recognition</a:t>
             </a:r>
           </a:p>
         </p:txBody>
@@ -6302,6 +6016,150 @@
         <p:spPr>
           <a:xfrm>
             <a:off x="1097280" y="2103120"/>
+            <a:ext cx="2743200" cy="548640"/>
+          </a:xfrm>
+          <a:prstGeom prst="rect">
+            <a:avLst/>
+          </a:prstGeom>
+          <a:noFill/>
+        </p:spPr>
+        <p:txBody>
+          <a:bodyPr wrap="square">
+            <a:spAutoFit/>
+          </a:bodyPr>
+          <a:lstStyle/>
+          <a:p>
+            <a:pPr algn="l">
+              <a:defRPr sz="2800" b="1" i="0">
+                <a:solidFill>
+                  <a:srgbClr val="059669"/>
+                </a:solidFill>
+                <a:latin typeface="Calibri"/>
+              </a:defRPr>
+            </a:pPr>
+            <a:r>
+              <a:t>50</a:t>
+            </a:r>
+          </a:p>
+        </p:txBody>
+      </p:sp>
+      <p:sp>
+        <p:nvSpPr>
+          <p:cNvPr id="6" name="TextBox 5"/>
+          <p:cNvSpPr txBox="1"/>
+          <p:nvPr/>
+        </p:nvSpPr>
+        <p:spPr>
+          <a:xfrm>
+            <a:off x="1097280" y="2651760"/>
+            <a:ext cx="9966960" cy="365760"/>
+          </a:xfrm>
+          <a:prstGeom prst="rect">
+            <a:avLst/>
+          </a:prstGeom>
+          <a:noFill/>
+        </p:spPr>
+        <p:txBody>
+          <a:bodyPr wrap="square">
+            <a:spAutoFit/>
+          </a:bodyPr>
+          <a:lstStyle/>
+          <a:p>
+            <a:pPr algn="l">
+              <a:defRPr sz="1400" b="0" i="0">
+                <a:solidFill>
+                  <a:srgbClr val="E2E2EA"/>
+                </a:solidFill>
+                <a:latin typeface="Calibri"/>
+              </a:defRPr>
+            </a:pPr>
+            <a:r>
+              <a:t>from Mykhailo Kukharskyi</a:t>
+            </a:r>
+          </a:p>
+        </p:txBody>
+      </p:sp>
+      <p:sp>
+        <p:nvSpPr>
+          <p:cNvPr id="7" name="TextBox 6"/>
+          <p:cNvSpPr txBox="1"/>
+          <p:nvPr/>
+        </p:nvSpPr>
+        <p:spPr>
+          <a:xfrm>
+            <a:off x="1097280" y="3108960"/>
+            <a:ext cx="9966960" cy="365760"/>
+          </a:xfrm>
+          <a:prstGeom prst="rect">
+            <a:avLst/>
+          </a:prstGeom>
+          <a:noFill/>
+        </p:spPr>
+        <p:txBody>
+          <a:bodyPr wrap="square">
+            <a:spAutoFit/>
+          </a:bodyPr>
+          <a:lstStyle/>
+          <a:p>
+            <a:pPr algn="l">
+              <a:defRPr sz="1400" b="1" i="0">
+                <a:solidFill>
+                  <a:srgbClr val="FFFFFF"/>
+                </a:solidFill>
+                <a:latin typeface="Calibri"/>
+              </a:defRPr>
+            </a:pPr>
+            <a:r>
+              <a:t>to: Gleb Krahotkin</a:t>
+            </a:r>
+          </a:p>
+        </p:txBody>
+      </p:sp>
+      <p:sp>
+        <p:nvSpPr>
+          <p:cNvPr id="8" name="TextBox 7"/>
+          <p:cNvSpPr txBox="1"/>
+          <p:nvPr/>
+        </p:nvSpPr>
+        <p:spPr>
+          <a:xfrm>
+            <a:off x="1097280" y="3749039"/>
+            <a:ext cx="9966960" cy="1097280"/>
+          </a:xfrm>
+          <a:prstGeom prst="rect">
+            <a:avLst/>
+          </a:prstGeom>
+          <a:noFill/>
+        </p:spPr>
+        <p:txBody>
+          <a:bodyPr wrap="square">
+            <a:spAutoFit/>
+          </a:bodyPr>
+          <a:lstStyle/>
+          <a:p>
+            <a:pPr algn="l">
+              <a:defRPr sz="1500" b="0" i="1">
+                <a:solidFill>
+                  <a:srgbClr val="E2E2EA"/>
+                </a:solidFill>
+                <a:latin typeface="Calibri"/>
+              </a:defRPr>
+            </a:pPr>
+            <a:r>
+              <a:t>"Outstanding Barcelona collaboration efforts"</a:t>
+            </a:r>
+          </a:p>
+        </p:txBody>
+      </p:sp>
+      <p:sp>
+        <p:nvSpPr>
+          <p:cNvPr id="9" name="TextBox 8"/>
+          <p:cNvSpPr txBox="1"/>
+          <p:nvPr/>
+        </p:nvSpPr>
+        <p:spPr>
+          <a:xfrm>
+            <a:off x="1097280" y="5120640"/>
             <a:ext cx="9966960" cy="457200"/>
           </a:xfrm>
           <a:prstGeom prst="rect">
@@ -6316,159 +6174,15 @@
           <a:lstStyle/>
           <a:p>
             <a:pPr algn="l">
-              <a:defRPr sz="1800" b="1" i="0">
-                <a:solidFill>
-                  <a:srgbClr val="FFFFFF"/>
-                </a:solidFill>
-                <a:latin typeface="Calibri"/>
-              </a:defRPr>
-            </a:pPr>
-            <a:r>
-              <a:t>Family First</a:t>
-            </a:r>
-          </a:p>
-        </p:txBody>
-      </p:sp>
-      <p:sp>
-        <p:nvSpPr>
-          <p:cNvPr id="6" name="TextBox 5"/>
-          <p:cNvSpPr txBox="1"/>
-          <p:nvPr/>
-        </p:nvSpPr>
-        <p:spPr>
-          <a:xfrm>
-            <a:off x="1371600" y="2743200"/>
-            <a:ext cx="9692640" cy="1828800"/>
-          </a:xfrm>
-          <a:prstGeom prst="rect">
-            <a:avLst/>
-          </a:prstGeom>
-          <a:noFill/>
-        </p:spPr>
-        <p:txBody>
-          <a:bodyPr wrap="square">
-            <a:spAutoFit/>
-          </a:bodyPr>
-          <a:lstStyle/>
-          <a:p>
-            <a:pPr algn="l">
-              <a:defRPr sz="1500" b="0" i="1">
-                <a:solidFill>
-                  <a:srgbClr val="E2E2EA"/>
-                </a:solidFill>
-                <a:latin typeface="Calibri"/>
-              </a:defRPr>
-            </a:pPr>
-            <a:r>
-              <a:t>"Pavel needs time off for a family emergency. The team is showing incredible support with hearts and prayers."</a:t>
-            </a:r>
-          </a:p>
-        </p:txBody>
-      </p:sp>
-      <p:sp>
-        <p:nvSpPr>
-          <p:cNvPr id="7" name="TextBox 6"/>
-          <p:cNvSpPr txBox="1"/>
-          <p:nvPr/>
-        </p:nvSpPr>
-        <p:spPr>
-          <a:xfrm>
-            <a:off x="1097280" y="4754880"/>
-            <a:ext cx="9966960" cy="365760"/>
-          </a:xfrm>
-          <a:prstGeom prst="rect">
-            <a:avLst/>
-          </a:prstGeom>
-          <a:noFill/>
-        </p:spPr>
-        <p:txBody>
-          <a:bodyPr wrap="square">
-            <a:spAutoFit/>
-          </a:bodyPr>
-          <a:lstStyle/>
-          <a:p>
-            <a:pPr algn="l">
-              <a:defRPr sz="1400" b="0" i="0">
-                <a:solidFill>
-                  <a:srgbClr val="8F95A3"/>
-                </a:solidFill>
-                <a:latin typeface="Calibri"/>
-              </a:defRPr>
-            </a:pPr>
-            <a:r>
-              <a:t>— Team Response</a:t>
-            </a:r>
-          </a:p>
-        </p:txBody>
-      </p:sp>
-      <p:sp>
-        <p:nvSpPr>
-          <p:cNvPr id="8" name="TextBox 7"/>
-          <p:cNvSpPr txBox="1"/>
-          <p:nvPr/>
-        </p:nvSpPr>
-        <p:spPr>
-          <a:xfrm>
-            <a:off x="1097280" y="5212080"/>
-            <a:ext cx="9966960" cy="365760"/>
-          </a:xfrm>
-          <a:prstGeom prst="rect">
-            <a:avLst/>
-          </a:prstGeom>
-          <a:noFill/>
-        </p:spPr>
-        <p:txBody>
-          <a:bodyPr wrap="square">
-            <a:spAutoFit/>
-          </a:bodyPr>
-          <a:lstStyle/>
-          <a:p>
-            <a:pPr algn="l">
-              <a:defRPr sz="1400" b="1" i="0">
-                <a:solidFill>
-                  <a:srgbClr val="EF4444"/>
-                </a:solidFill>
-                <a:latin typeface="Calibri"/>
-              </a:defRPr>
-            </a:pPr>
-            <a:r>
-              <a:t>39</a:t>
-            </a:r>
-          </a:p>
-        </p:txBody>
-      </p:sp>
-      <p:sp>
-        <p:nvSpPr>
-          <p:cNvPr id="9" name="TextBox 8"/>
-          <p:cNvSpPr txBox="1"/>
-          <p:nvPr/>
-        </p:nvSpPr>
-        <p:spPr>
-          <a:xfrm>
-            <a:off x="1097280" y="5760720"/>
-            <a:ext cx="9966960" cy="274320"/>
-          </a:xfrm>
-          <a:prstGeom prst="rect">
-            <a:avLst/>
-          </a:prstGeom>
-          <a:noFill/>
-        </p:spPr>
-        <p:txBody>
-          <a:bodyPr wrap="square">
-            <a:spAutoFit/>
-          </a:bodyPr>
-          <a:lstStyle/>
-          <a:p>
-            <a:pPr algn="l">
-              <a:defRPr sz="1100" b="0" i="0">
-                <a:solidFill>
-                  <a:srgbClr val="5C6270"/>
-                </a:solidFill>
-                <a:latin typeface="Calibri"/>
-              </a:defRPr>
-            </a:pPr>
-            <a:r>
-              <a:t>#general</a:t>
+              <a:defRPr sz="1200" b="1" i="0">
+                <a:solidFill>
+                  <a:srgbClr val="059669"/>
+                </a:solidFill>
+                <a:latin typeface="Calibri"/>
+              </a:defRPr>
+            </a:pPr>
+            <a:r>
+              <a:t>Excellence · Teamwork</a:t>
             </a:r>
           </a:p>
         </p:txBody>
@@ -6514,7 +6228,7 @@
             <a:avLst/>
           </a:prstGeom>
           <a:solidFill>
-            <a:srgbClr val="10B981"/>
+            <a:srgbClr val="7C3AED"/>
           </a:solidFill>
           <a:ln>
             <a:noFill/>
@@ -6567,13 +6281,13 @@
             <a:pPr algn="l">
               <a:defRPr sz="1000" b="1">
                 <a:solidFill>
-                  <a:srgbClr val="10B981"/>
-                </a:solidFill>
-                <a:latin typeface="Calibri"/>
-              </a:defRPr>
-            </a:pPr>
-            <a:r>
-              <a:t>🚀  WIN</a:t>
+                  <a:srgbClr val="7C3AED"/>
+                </a:solidFill>
+                <a:latin typeface="Calibri"/>
+              </a:defRPr>
+            </a:pPr>
+            <a:r>
+              <a:t>🙌  CLAPS</a:t>
             </a:r>
           </a:p>
         </p:txBody>
@@ -6603,13 +6317,13 @@
             <a:pPr algn="l">
               <a:defRPr sz="3200" b="1" i="0">
                 <a:solidFill>
-                  <a:srgbClr val="10B981"/>
-                </a:solidFill>
-                <a:latin typeface="Calibri"/>
-              </a:defRPr>
-            </a:pPr>
-            <a:r>
-              <a:t>Innovation Momentum</a:t>
+                  <a:srgbClr val="7C3AED"/>
+                </a:solidFill>
+                <a:latin typeface="Calibri"/>
+              </a:defRPr>
+            </a:pPr>
+            <a:r>
+              <a:t>Team Excellence</a:t>
             </a:r>
           </a:p>
         </p:txBody>
@@ -6623,29 +6337,29 @@
         <p:spPr>
           <a:xfrm>
             <a:off x="1097280" y="2103120"/>
-            <a:ext cx="4572000" cy="822960"/>
-          </a:xfrm>
-          <a:prstGeom prst="rect">
-            <a:avLst/>
-          </a:prstGeom>
-          <a:noFill/>
-        </p:spPr>
-        <p:txBody>
-          <a:bodyPr wrap="square">
-            <a:spAutoFit/>
-          </a:bodyPr>
-          <a:lstStyle/>
-          <a:p>
-            <a:pPr algn="l">
-              <a:defRPr sz="4800" b="1" i="0">
-                <a:solidFill>
-                  <a:srgbClr val="10B981"/>
-                </a:solidFill>
-                <a:latin typeface="Calibri"/>
-              </a:defRPr>
-            </a:pPr>
-            <a:r>
-              <a:t>Rapid</a:t>
+            <a:ext cx="2743200" cy="548640"/>
+          </a:xfrm>
+          <a:prstGeom prst="rect">
+            <a:avLst/>
+          </a:prstGeom>
+          <a:noFill/>
+        </p:spPr>
+        <p:txBody>
+          <a:bodyPr wrap="square">
+            <a:spAutoFit/>
+          </a:bodyPr>
+          <a:lstStyle/>
+          <a:p>
+            <a:pPr algn="l">
+              <a:defRPr sz="2800" b="1" i="0">
+                <a:solidFill>
+                  <a:srgbClr val="7C3AED"/>
+                </a:solidFill>
+                <a:latin typeface="Calibri"/>
+              </a:defRPr>
+            </a:pPr>
+            <a:r>
+              <a:t>50</a:t>
             </a:r>
           </a:p>
         </p:txBody>
@@ -6658,30 +6372,30 @@
         </p:nvSpPr>
         <p:spPr>
           <a:xfrm>
-            <a:off x="1097280" y="2834640"/>
-            <a:ext cx="4572000" cy="365760"/>
-          </a:xfrm>
-          <a:prstGeom prst="rect">
-            <a:avLst/>
-          </a:prstGeom>
-          <a:noFill/>
-        </p:spPr>
-        <p:txBody>
-          <a:bodyPr wrap="square">
-            <a:spAutoFit/>
-          </a:bodyPr>
-          <a:lstStyle/>
-          <a:p>
-            <a:pPr algn="l">
-              <a:defRPr sz="1200" b="0" i="0">
-                <a:solidFill>
-                  <a:srgbClr val="8F95A3"/>
-                </a:solidFill>
-                <a:latin typeface="Calibri"/>
-              </a:defRPr>
-            </a:pPr>
-            <a:r>
-              <a:t>Tool Development</a:t>
+            <a:off x="1097280" y="2651760"/>
+            <a:ext cx="9966960" cy="365760"/>
+          </a:xfrm>
+          <a:prstGeom prst="rect">
+            <a:avLst/>
+          </a:prstGeom>
+          <a:noFill/>
+        </p:spPr>
+        <p:txBody>
+          <a:bodyPr wrap="square">
+            <a:spAutoFit/>
+          </a:bodyPr>
+          <a:lstStyle/>
+          <a:p>
+            <a:pPr algn="l">
+              <a:defRPr sz="1400" b="0" i="0">
+                <a:solidFill>
+                  <a:srgbClr val="E2E2EA"/>
+                </a:solidFill>
+                <a:latin typeface="Calibri"/>
+              </a:defRPr>
+            </a:pPr>
+            <a:r>
+              <a:t>from Viktor Trykolenko</a:t>
             </a:r>
           </a:p>
         </p:txBody>
@@ -6694,7 +6408,7 @@
         </p:nvSpPr>
         <p:spPr>
           <a:xfrm>
-            <a:off x="1097280" y="3291840"/>
+            <a:off x="1097280" y="3108960"/>
             <a:ext cx="9966960" cy="365760"/>
           </a:xfrm>
           <a:prstGeom prst="rect">
@@ -6709,7 +6423,43 @@
           <a:lstStyle/>
           <a:p>
             <a:pPr algn="l">
-              <a:defRPr sz="1400" b="0" i="0">
+              <a:defRPr sz="1400" b="1" i="0">
+                <a:solidFill>
+                  <a:srgbClr val="FFFFFF"/>
+                </a:solidFill>
+                <a:latin typeface="Calibri"/>
+              </a:defRPr>
+            </a:pPr>
+            <a:r>
+              <a:t>to: Iurii Kotov</a:t>
+            </a:r>
+          </a:p>
+        </p:txBody>
+      </p:sp>
+      <p:sp>
+        <p:nvSpPr>
+          <p:cNvPr id="8" name="TextBox 7"/>
+          <p:cNvSpPr txBox="1"/>
+          <p:nvPr/>
+        </p:nvSpPr>
+        <p:spPr>
+          <a:xfrm>
+            <a:off x="1097280" y="3749039"/>
+            <a:ext cx="9966960" cy="1097280"/>
+          </a:xfrm>
+          <a:prstGeom prst="rect">
+            <a:avLst/>
+          </a:prstGeom>
+          <a:noFill/>
+        </p:spPr>
+        <p:txBody>
+          <a:bodyPr wrap="square">
+            <a:spAutoFit/>
+          </a:bodyPr>
+          <a:lstStyle/>
+          <a:p>
+            <a:pPr algn="l">
+              <a:defRPr sz="1500" b="0" i="1">
                 <a:solidFill>
                   <a:srgbClr val="E2E2EA"/>
                 </a:solidFill>
@@ -6717,20 +6467,20 @@
               </a:defRPr>
             </a:pPr>
             <a:r>
-              <a:t>by Non-Engineering Teams</a:t>
-            </a:r>
-          </a:p>
-        </p:txBody>
-      </p:sp>
-      <p:sp>
-        <p:nvSpPr>
-          <p:cNvPr id="8" name="TextBox 7"/>
-          <p:cNvSpPr txBox="1"/>
-          <p:nvPr/>
-        </p:nvSpPr>
-        <p:spPr>
-          <a:xfrm>
-            <a:off x="1097280" y="3840480"/>
+              <a:t>"Exceptional performance and dedication"</a:t>
+            </a:r>
+          </a:p>
+        </p:txBody>
+      </p:sp>
+      <p:sp>
+        <p:nvSpPr>
+          <p:cNvPr id="9" name="TextBox 8"/>
+          <p:cNvSpPr txBox="1"/>
+          <p:nvPr/>
+        </p:nvSpPr>
+        <p:spPr>
+          <a:xfrm>
+            <a:off x="1097280" y="5120640"/>
             <a:ext cx="9966960" cy="457200"/>
           </a:xfrm>
           <a:prstGeom prst="rect">
@@ -6745,87 +6495,15 @@
           <a:lstStyle/>
           <a:p>
             <a:pPr algn="l">
-              <a:defRPr sz="1800" b="1" i="0">
-                <a:solidFill>
-                  <a:srgbClr val="FFFFFF"/>
-                </a:solidFill>
-                <a:latin typeface="Calibri"/>
-              </a:defRPr>
-            </a:pPr>
-            <a:r>
-              <a:t>Building at Lightning Speed</a:t>
-            </a:r>
-          </a:p>
-        </p:txBody>
-      </p:sp>
-      <p:sp>
-        <p:nvSpPr>
-          <p:cNvPr id="9" name="TextBox 8"/>
-          <p:cNvSpPr txBox="1"/>
-          <p:nvPr/>
-        </p:nvSpPr>
-        <p:spPr>
-          <a:xfrm>
-            <a:off x="1097280" y="4389120"/>
-            <a:ext cx="9966960" cy="914400"/>
-          </a:xfrm>
-          <a:prstGeom prst="rect">
-            <a:avLst/>
-          </a:prstGeom>
-          <a:noFill/>
-        </p:spPr>
-        <p:txBody>
-          <a:bodyPr wrap="square">
-            <a:spAutoFit/>
-          </a:bodyPr>
-          <a:lstStyle/>
-          <a:p>
-            <a:pPr algn="l">
-              <a:defRPr sz="1400" b="0" i="0">
-                <a:solidFill>
-                  <a:srgbClr val="E2E2EA"/>
-                </a:solidFill>
-                <a:latin typeface="Calibri"/>
-              </a:defRPr>
-            </a:pPr>
-            <a:r>
-              <a:t>Non-engineering teams are creating useful tools faster than ever, showing incredible learning velocity and innovation mindset.</a:t>
-            </a:r>
-          </a:p>
-        </p:txBody>
-      </p:sp>
-      <p:sp>
-        <p:nvSpPr>
-          <p:cNvPr id="10" name="TextBox 9"/>
-          <p:cNvSpPr txBox="1"/>
-          <p:nvPr/>
-        </p:nvSpPr>
-        <p:spPr>
-          <a:xfrm>
-            <a:off x="1097280" y="5486400"/>
-            <a:ext cx="9966960" cy="457200"/>
-          </a:xfrm>
-          <a:prstGeom prst="rect">
-            <a:avLst/>
-          </a:prstGeom>
-          <a:noFill/>
-        </p:spPr>
-        <p:txBody>
-          <a:bodyPr wrap="square">
-            <a:spAutoFit/>
-          </a:bodyPr>
-          <a:lstStyle/>
-          <a:p>
-            <a:pPr algn="l">
-              <a:defRPr sz="1300" b="0" i="1">
-                <a:solidFill>
-                  <a:srgbClr val="8F95A3"/>
-                </a:solidFill>
-                <a:latin typeface="Calibri"/>
-              </a:defRPr>
-            </a:pPr>
-            <a:r>
-              <a:t>💬 "We're moving in the right direction with cross-team innovation"</a:t>
+              <a:defRPr sz="1200" b="1" i="0">
+                <a:solidFill>
+                  <a:srgbClr val="7C3AED"/>
+                </a:solidFill>
+                <a:latin typeface="Calibri"/>
+              </a:defRPr>
+            </a:pPr>
+            <a:r>
+              <a:t>Excellence · Commitment</a:t>
             </a:r>
           </a:p>
         </p:txBody>
@@ -6871,7 +6549,7 @@
             <a:avLst/>
           </a:prstGeom>
           <a:solidFill>
-            <a:srgbClr val="7C3AED"/>
+            <a:srgbClr val="DC2626"/>
           </a:solidFill>
           <a:ln>
             <a:noFill/>
@@ -6924,13 +6602,13 @@
             <a:pPr algn="l">
               <a:defRPr sz="1000" b="1">
                 <a:solidFill>
-                  <a:srgbClr val="7C3AED"/>
-                </a:solidFill>
-                <a:latin typeface="Calibri"/>
-              </a:defRPr>
-            </a:pPr>
-            <a:r>
-              <a:t>🔒  WIN</a:t>
+                  <a:srgbClr val="DC2626"/>
+                </a:solidFill>
+                <a:latin typeface="Calibri"/>
+              </a:defRPr>
+            </a:pPr>
+            <a:r>
+              <a:t>⭐  CLAPS</a:t>
             </a:r>
           </a:p>
         </p:txBody>
@@ -6960,13 +6638,13 @@
             <a:pPr algn="l">
               <a:defRPr sz="3200" b="1" i="0">
                 <a:solidFill>
-                  <a:srgbClr val="7C3AED"/>
-                </a:solidFill>
-                <a:latin typeface="Calibri"/>
-              </a:defRPr>
-            </a:pPr>
-            <a:r>
-              <a:t>Security Excellence</a:t>
+                  <a:srgbClr val="DC2626"/>
+                </a:solidFill>
+                <a:latin typeface="Calibri"/>
+              </a:defRPr>
+            </a:pPr>
+            <a:r>
+              <a:t>Outstanding Achievement</a:t>
             </a:r>
           </a:p>
         </p:txBody>
@@ -6980,29 +6658,29 @@
         <p:spPr>
           <a:xfrm>
             <a:off x="1097280" y="2103120"/>
-            <a:ext cx="4572000" cy="822960"/>
-          </a:xfrm>
-          <a:prstGeom prst="rect">
-            <a:avLst/>
-          </a:prstGeom>
-          <a:noFill/>
-        </p:spPr>
-        <p:txBody>
-          <a:bodyPr wrap="square">
-            <a:spAutoFit/>
-          </a:bodyPr>
-          <a:lstStyle/>
-          <a:p>
-            <a:pPr algn="l">
-              <a:defRPr sz="4800" b="1" i="0">
-                <a:solidFill>
-                  <a:srgbClr val="7C3AED"/>
-                </a:solidFill>
-                <a:latin typeface="Calibri"/>
-              </a:defRPr>
-            </a:pPr>
-            <a:r>
-              <a:t>Enhanced</a:t>
+            <a:ext cx="2743200" cy="548640"/>
+          </a:xfrm>
+          <a:prstGeom prst="rect">
+            <a:avLst/>
+          </a:prstGeom>
+          <a:noFill/>
+        </p:spPr>
+        <p:txBody>
+          <a:bodyPr wrap="square">
+            <a:spAutoFit/>
+          </a:bodyPr>
+          <a:lstStyle/>
+          <a:p>
+            <a:pPr algn="l">
+              <a:defRPr sz="2800" b="1" i="0">
+                <a:solidFill>
+                  <a:srgbClr val="DC2626"/>
+                </a:solidFill>
+                <a:latin typeface="Calibri"/>
+              </a:defRPr>
+            </a:pPr>
+            <a:r>
+              <a:t>50</a:t>
             </a:r>
           </a:p>
         </p:txBody>
@@ -7015,30 +6693,30 @@
         </p:nvSpPr>
         <p:spPr>
           <a:xfrm>
-            <a:off x="1097280" y="2834640"/>
-            <a:ext cx="4572000" cy="365760"/>
-          </a:xfrm>
-          <a:prstGeom prst="rect">
-            <a:avLst/>
-          </a:prstGeom>
-          <a:noFill/>
-        </p:spPr>
-        <p:txBody>
-          <a:bodyPr wrap="square">
-            <a:spAutoFit/>
-          </a:bodyPr>
-          <a:lstStyle/>
-          <a:p>
-            <a:pPr algn="l">
-              <a:defRPr sz="1200" b="0" i="0">
-                <a:solidFill>
-                  <a:srgbClr val="8F95A3"/>
-                </a:solidFill>
-                <a:latin typeface="Calibri"/>
-              </a:defRPr>
-            </a:pPr>
-            <a:r>
-              <a:t>Security Practices</a:t>
+            <a:off x="1097280" y="2651760"/>
+            <a:ext cx="9966960" cy="365760"/>
+          </a:xfrm>
+          <a:prstGeom prst="rect">
+            <a:avLst/>
+          </a:prstGeom>
+          <a:noFill/>
+        </p:spPr>
+        <p:txBody>
+          <a:bodyPr wrap="square">
+            <a:spAutoFit/>
+          </a:bodyPr>
+          <a:lstStyle/>
+          <a:p>
+            <a:pPr algn="l">
+              <a:defRPr sz="1400" b="0" i="0">
+                <a:solidFill>
+                  <a:srgbClr val="E2E2EA"/>
+                </a:solidFill>
+                <a:latin typeface="Calibri"/>
+              </a:defRPr>
+            </a:pPr>
+            <a:r>
+              <a:t>from Jasmine Nunez</a:t>
             </a:r>
           </a:p>
         </p:txBody>
@@ -7051,7 +6729,7 @@
         </p:nvSpPr>
         <p:spPr>
           <a:xfrm>
-            <a:off x="1097280" y="3291840"/>
+            <a:off x="1097280" y="3108960"/>
             <a:ext cx="9966960" cy="365760"/>
           </a:xfrm>
           <a:prstGeom prst="rect">
@@ -7066,7 +6744,43 @@
           <a:lstStyle/>
           <a:p>
             <a:pPr algn="l">
-              <a:defRPr sz="1400" b="0" i="0">
+              <a:defRPr sz="1400" b="1" i="0">
+                <a:solidFill>
+                  <a:srgbClr val="FFFFFF"/>
+                </a:solidFill>
+                <a:latin typeface="Calibri"/>
+              </a:defRPr>
+            </a:pPr>
+            <a:r>
+              <a:t>to: Michelle Walter</a:t>
+            </a:r>
+          </a:p>
+        </p:txBody>
+      </p:sp>
+      <p:sp>
+        <p:nvSpPr>
+          <p:cNvPr id="8" name="TextBox 7"/>
+          <p:cNvSpPr txBox="1"/>
+          <p:nvPr/>
+        </p:nvSpPr>
+        <p:spPr>
+          <a:xfrm>
+            <a:off x="1097280" y="3749039"/>
+            <a:ext cx="9966960" cy="1097280"/>
+          </a:xfrm>
+          <a:prstGeom prst="rect">
+            <a:avLst/>
+          </a:prstGeom>
+          <a:noFill/>
+        </p:spPr>
+        <p:txBody>
+          <a:bodyPr wrap="square">
+            <a:spAutoFit/>
+          </a:bodyPr>
+          <a:lstStyle/>
+          <a:p>
+            <a:pPr algn="l">
+              <a:defRPr sz="1500" b="0" i="1">
                 <a:solidFill>
                   <a:srgbClr val="E2E2EA"/>
                 </a:solidFill>
@@ -7074,20 +6788,20 @@
               </a:defRPr>
             </a:pPr>
             <a:r>
-              <a:t>by Engineering Team</a:t>
-            </a:r>
-          </a:p>
-        </p:txBody>
-      </p:sp>
-      <p:sp>
-        <p:nvSpPr>
-          <p:cNvPr id="8" name="TextBox 7"/>
-          <p:cNvSpPr txBox="1"/>
-          <p:nvPr/>
-        </p:nvSpPr>
-        <p:spPr>
-          <a:xfrm>
-            <a:off x="1097280" y="3840480"/>
+              <a:t>"Delivering exceptional results"</a:t>
+            </a:r>
+          </a:p>
+        </p:txBody>
+      </p:sp>
+      <p:sp>
+        <p:nvSpPr>
+          <p:cNvPr id="9" name="TextBox 8"/>
+          <p:cNvSpPr txBox="1"/>
+          <p:nvPr/>
+        </p:nvSpPr>
+        <p:spPr>
+          <a:xfrm>
+            <a:off x="1097280" y="5120640"/>
             <a:ext cx="9966960" cy="457200"/>
           </a:xfrm>
           <a:prstGeom prst="rect">
@@ -7102,87 +6816,15 @@
           <a:lstStyle/>
           <a:p>
             <a:pPr algn="l">
-              <a:defRPr sz="1800" b="1" i="0">
-                <a:solidFill>
-                  <a:srgbClr val="FFFFFF"/>
-                </a:solidFill>
-                <a:latin typeface="Calibri"/>
-              </a:defRPr>
-            </a:pPr>
-            <a:r>
-              <a:t>Scaling with Security in Mind</a:t>
-            </a:r>
-          </a:p>
-        </p:txBody>
-      </p:sp>
-      <p:sp>
-        <p:nvSpPr>
-          <p:cNvPr id="9" name="TextBox 8"/>
-          <p:cNvSpPr txBox="1"/>
-          <p:nvPr/>
-        </p:nvSpPr>
-        <p:spPr>
-          <a:xfrm>
-            <a:off x="1097280" y="4389120"/>
-            <a:ext cx="9966960" cy="914400"/>
-          </a:xfrm>
-          <a:prstGeom prst="rect">
-            <a:avLst/>
-          </a:prstGeom>
-          <a:noFill/>
-        </p:spPr>
-        <p:txBody>
-          <a:bodyPr wrap="square">
-            <a:spAutoFit/>
-          </a:bodyPr>
-          <a:lstStyle/>
-          <a:p>
-            <a:pPr algn="l">
-              <a:defRPr sz="1400" b="0" i="0">
-                <a:solidFill>
-                  <a:srgbClr val="E2E2EA"/>
-                </a:solidFill>
-                <a:latin typeface="Calibri"/>
-              </a:defRPr>
-            </a:pPr>
-            <a:r>
-              <a:t>As we grow rapidly, the focus on proper engineering and security practices ensures our foundation remains strong.</a:t>
-            </a:r>
-          </a:p>
-        </p:txBody>
-      </p:sp>
-      <p:sp>
-        <p:nvSpPr>
-          <p:cNvPr id="10" name="TextBox 9"/>
-          <p:cNvSpPr txBox="1"/>
-          <p:nvPr/>
-        </p:nvSpPr>
-        <p:spPr>
-          <a:xfrm>
-            <a:off x="1097280" y="5486400"/>
-            <a:ext cx="9966960" cy="457200"/>
-          </a:xfrm>
-          <a:prstGeom prst="rect">
-            <a:avLst/>
-          </a:prstGeom>
-          <a:noFill/>
-        </p:spPr>
-        <p:txBody>
-          <a:bodyPr wrap="square">
-            <a:spAutoFit/>
-          </a:bodyPr>
-          <a:lstStyle/>
-          <a:p>
-            <a:pPr algn="l">
-              <a:defRPr sz="1300" b="0" i="1">
-                <a:solidFill>
-                  <a:srgbClr val="8F95A3"/>
-                </a:solidFill>
-                <a:latin typeface="Calibri"/>
-              </a:defRPr>
-            </a:pPr>
-            <a:r>
-              <a:t>💬 "Growth without compromising on security standards"</a:t>
+              <a:defRPr sz="1200" b="1" i="0">
+                <a:solidFill>
+                  <a:srgbClr val="DC2626"/>
+                </a:solidFill>
+                <a:latin typeface="Calibri"/>
+              </a:defRPr>
+            </a:pPr>
+            <a:r>
+              <a:t>Excellence · Impact</a:t>
             </a:r>
           </a:p>
         </p:txBody>
@@ -7228,7 +6870,7 @@
             <a:avLst/>
           </a:prstGeom>
           <a:solidFill>
-            <a:srgbClr val="F59E0B"/>
+            <a:srgbClr val="EA580C"/>
           </a:solidFill>
           <a:ln>
             <a:noFill/>
@@ -7281,13 +6923,13 @@
             <a:pPr algn="l">
               <a:defRPr sz="1000" b="1">
                 <a:solidFill>
-                  <a:srgbClr val="F59E0B"/>
-                </a:solidFill>
-                <a:latin typeface="Calibri"/>
-              </a:defRPr>
-            </a:pPr>
-            <a:r>
-              <a:t>👏  CLAPS</a:t>
+                  <a:srgbClr val="EA580C"/>
+                </a:solidFill>
+                <a:latin typeface="Calibri"/>
+              </a:defRPr>
+            </a:pPr>
+            <a:r>
+              <a:t>🔥  CLAPS</a:t>
             </a:r>
           </a:p>
         </p:txBody>
@@ -7317,13 +6959,13 @@
             <a:pPr algn="l">
               <a:defRPr sz="3200" b="1" i="0">
                 <a:solidFill>
-                  <a:srgbClr val="F59E0B"/>
-                </a:solidFill>
-                <a:latin typeface="Calibri"/>
-              </a:defRPr>
-            </a:pPr>
-            <a:r>
-              <a:t>Team Recognition</a:t>
+                  <a:srgbClr val="EA580C"/>
+                </a:solidFill>
+                <a:latin typeface="Calibri"/>
+              </a:defRPr>
+            </a:pPr>
+            <a:r>
+              <a:t>Multi-Team Recognition</a:t>
             </a:r>
           </a:p>
         </p:txBody>
@@ -7353,13 +6995,13 @@
             <a:pPr algn="l">
               <a:defRPr sz="2800" b="1" i="0">
                 <a:solidFill>
-                  <a:srgbClr val="F59E0B"/>
-                </a:solidFill>
-                <a:latin typeface="Calibri"/>
-              </a:defRPr>
-            </a:pPr>
-            <a:r>
-              <a:t>100</a:t>
+                  <a:srgbClr val="EA580C"/>
+                </a:solidFill>
+                <a:latin typeface="Calibri"/>
+              </a:defRPr>
+            </a:pPr>
+            <a:r>
+              <a:t>50</a:t>
             </a:r>
           </a:p>
         </p:txBody>
@@ -7395,7 +7037,7 @@
               </a:defRPr>
             </a:pPr>
             <a:r>
-              <a:t>from Mykhailo Kukharskyi &amp; Artem Pchelintsev &amp; Mikita Dzianisevich</a:t>
+              <a:t>from Michael Lotfy</a:t>
             </a:r>
           </a:p>
         </p:txBody>
@@ -7431,7 +7073,7 @@
               </a:defRPr>
             </a:pPr>
             <a:r>
-              <a:t>to: Gleb Krahotkin</a:t>
+              <a:t>to: Issa Isahakyan</a:t>
             </a:r>
           </a:p>
         </p:txBody>
@@ -7467,7 +7109,7 @@
               </a:defRPr>
             </a:pPr>
             <a:r>
-              <a:t>"Outstanding performance that earned massive recognition from multiple team leads"</a:t>
+              <a:t>"Cross-functional excellence and leadership"</a:t>
             </a:r>
           </a:p>
         </p:txBody>
@@ -7497,13 +7139,13 @@
             <a:pPr algn="l">
               <a:defRPr sz="1200" b="1" i="0">
                 <a:solidFill>
-                  <a:srgbClr val="F59E0B"/>
-                </a:solidFill>
-                <a:latin typeface="Calibri"/>
-              </a:defRPr>
-            </a:pPr>
-            <a:r>
-              <a:t>Excellence · Impact</a:t>
+                  <a:srgbClr val="EA580C"/>
+                </a:solidFill>
+                <a:latin typeface="Calibri"/>
+              </a:defRPr>
+            </a:pPr>
+            <a:r>
+              <a:t>Leadership · Collaboration</a:t>
             </a:r>
           </a:p>
         </p:txBody>
@@ -7549,7 +7191,7 @@
             <a:avLst/>
           </a:prstGeom>
           <a:solidFill>
-            <a:srgbClr val="06B6D4"/>
+            <a:srgbClr val="0891B2"/>
           </a:solidFill>
           <a:ln>
             <a:noFill/>
@@ -7602,13 +7244,13 @@
             <a:pPr algn="l">
               <a:defRPr sz="1000" b="1">
                 <a:solidFill>
-                  <a:srgbClr val="06B6D4"/>
-                </a:solidFill>
-                <a:latin typeface="Calibri"/>
-              </a:defRPr>
-            </a:pPr>
-            <a:r>
-              <a:t>🌟  CLAPS</a:t>
+                  <a:srgbClr val="0891B2"/>
+                </a:solidFill>
+                <a:latin typeface="Calibri"/>
+              </a:defRPr>
+            </a:pPr>
+            <a:r>
+              <a:t>😅  OFFICE LIFE</a:t>
             </a:r>
           </a:p>
         </p:txBody>
@@ -7638,13 +7280,13 @@
             <a:pPr algn="l">
               <a:defRPr sz="3200" b="1" i="0">
                 <a:solidFill>
-                  <a:srgbClr val="06B6D4"/>
-                </a:solidFill>
-                <a:latin typeface="Calibri"/>
-              </a:defRPr>
-            </a:pPr>
-            <a:r>
-              <a:t>Leadership Recognition</a:t>
+                  <a:srgbClr val="0891B2"/>
+                </a:solidFill>
+                <a:latin typeface="Calibri"/>
+              </a:defRPr>
+            </a:pPr>
+            <a:r>
+              <a:t>Family First</a:t>
             </a:r>
           </a:p>
         </p:txBody>
@@ -7658,29 +7300,29 @@
         <p:spPr>
           <a:xfrm>
             <a:off x="1097280" y="2103120"/>
-            <a:ext cx="2743200" cy="548640"/>
-          </a:xfrm>
-          <a:prstGeom prst="rect">
-            <a:avLst/>
-          </a:prstGeom>
-          <a:noFill/>
-        </p:spPr>
-        <p:txBody>
-          <a:bodyPr wrap="square">
-            <a:spAutoFit/>
-          </a:bodyPr>
-          <a:lstStyle/>
-          <a:p>
-            <a:pPr algn="l">
-              <a:defRPr sz="2800" b="1" i="0">
-                <a:solidFill>
-                  <a:srgbClr val="06B6D4"/>
-                </a:solidFill>
-                <a:latin typeface="Calibri"/>
-              </a:defRPr>
-            </a:pPr>
-            <a:r>
-              <a:t>50</a:t>
+            <a:ext cx="9966960" cy="457200"/>
+          </a:xfrm>
+          <a:prstGeom prst="rect">
+            <a:avLst/>
+          </a:prstGeom>
+          <a:noFill/>
+        </p:spPr>
+        <p:txBody>
+          <a:bodyPr wrap="square">
+            <a:spAutoFit/>
+          </a:bodyPr>
+          <a:lstStyle/>
+          <a:p>
+            <a:pPr algn="l">
+              <a:defRPr sz="1800" b="1" i="0">
+                <a:solidFill>
+                  <a:srgbClr val="FFFFFF"/>
+                </a:solidFill>
+                <a:latin typeface="Calibri"/>
+              </a:defRPr>
+            </a:pPr>
+            <a:r>
+              <a:t>Sometimes life happens</a:t>
             </a:r>
           </a:p>
         </p:txBody>
@@ -7693,7 +7335,43 @@
         </p:nvSpPr>
         <p:spPr>
           <a:xfrm>
-            <a:off x="1097280" y="2651760"/>
+            <a:off x="1371600" y="2743200"/>
+            <a:ext cx="9692640" cy="1828800"/>
+          </a:xfrm>
+          <a:prstGeom prst="rect">
+            <a:avLst/>
+          </a:prstGeom>
+          <a:noFill/>
+        </p:spPr>
+        <p:txBody>
+          <a:bodyPr wrap="square">
+            <a:spAutoFit/>
+          </a:bodyPr>
+          <a:lstStyle/>
+          <a:p>
+            <a:pPr algn="l">
+              <a:defRPr sz="1500" b="0" i="1">
+                <a:solidFill>
+                  <a:srgbClr val="E2E2EA"/>
+                </a:solidFill>
+                <a:latin typeface="Calibri"/>
+              </a:defRPr>
+            </a:pPr>
+            <a:r>
+              <a:t>"Pavel had to skip Friday meetings due to a family emergency, reminding us all that family comes first. The team rallied with hearts, prayers, and support."</a:t>
+            </a:r>
+          </a:p>
+        </p:txBody>
+      </p:sp>
+      <p:sp>
+        <p:nvSpPr>
+          <p:cNvPr id="7" name="TextBox 6"/>
+          <p:cNvSpPr txBox="1"/>
+          <p:nvPr/>
+        </p:nvSpPr>
+        <p:spPr>
+          <a:xfrm>
+            <a:off x="1097280" y="4754880"/>
             <a:ext cx="9966960" cy="365760"/>
           </a:xfrm>
           <a:prstGeom prst="rect">
@@ -7710,26 +7388,26 @@
             <a:pPr algn="l">
               <a:defRPr sz="1400" b="0" i="0">
                 <a:solidFill>
-                  <a:srgbClr val="E2E2EA"/>
-                </a:solidFill>
-                <a:latin typeface="Calibri"/>
-              </a:defRPr>
-            </a:pPr>
-            <a:r>
-              <a:t>from Viktor Trykolenko &amp; Michelle Walter &amp; Michael Lotfy</a:t>
-            </a:r>
-          </a:p>
-        </p:txBody>
-      </p:sp>
-      <p:sp>
-        <p:nvSpPr>
-          <p:cNvPr id="7" name="TextBox 6"/>
-          <p:cNvSpPr txBox="1"/>
-          <p:nvPr/>
-        </p:nvSpPr>
-        <p:spPr>
-          <a:xfrm>
-            <a:off x="1097280" y="3108960"/>
+                  <a:srgbClr val="8F95A3"/>
+                </a:solidFill>
+                <a:latin typeface="Calibri"/>
+              </a:defRPr>
+            </a:pPr>
+            <a:r>
+              <a:t>— Team Response</a:t>
+            </a:r>
+          </a:p>
+        </p:txBody>
+      </p:sp>
+      <p:sp>
+        <p:nvSpPr>
+          <p:cNvPr id="8" name="TextBox 7"/>
+          <p:cNvSpPr txBox="1"/>
+          <p:nvPr/>
+        </p:nvSpPr>
+        <p:spPr>
+          <a:xfrm>
+            <a:off x="1097280" y="5212080"/>
             <a:ext cx="9966960" cy="365760"/>
           </a:xfrm>
           <a:prstGeom prst="rect">
@@ -7746,49 +7424,13 @@
             <a:pPr algn="l">
               <a:defRPr sz="1400" b="1" i="0">
                 <a:solidFill>
-                  <a:srgbClr val="FFFFFF"/>
-                </a:solidFill>
-                <a:latin typeface="Calibri"/>
-              </a:defRPr>
-            </a:pPr>
-            <a:r>
-              <a:t>to: Iurii Kotov, Michelle Walter, Isahakyan</a:t>
-            </a:r>
-          </a:p>
-        </p:txBody>
-      </p:sp>
-      <p:sp>
-        <p:nvSpPr>
-          <p:cNvPr id="8" name="TextBox 7"/>
-          <p:cNvSpPr txBox="1"/>
-          <p:nvPr/>
-        </p:nvSpPr>
-        <p:spPr>
-          <a:xfrm>
-            <a:off x="1097280" y="3749039"/>
-            <a:ext cx="9966960" cy="1097280"/>
-          </a:xfrm>
-          <a:prstGeom prst="rect">
-            <a:avLst/>
-          </a:prstGeom>
-          <a:noFill/>
-        </p:spPr>
-        <p:txBody>
-          <a:bodyPr wrap="square">
-            <a:spAutoFit/>
-          </a:bodyPr>
-          <a:lstStyle/>
-          <a:p>
-            <a:pPr algn="l">
-              <a:defRPr sz="1500" b="0" i="1">
-                <a:solidFill>
-                  <a:srgbClr val="E2E2EA"/>
-                </a:solidFill>
-                <a:latin typeface="Calibri"/>
-              </a:defRPr>
-            </a:pPr>
-            <a:r>
-              <a:t>"Exceptional leadership and contribution across multiple projects"</a:t>
+                  <a:srgbClr val="0891B2"/>
+                </a:solidFill>
+                <a:latin typeface="Calibri"/>
+              </a:defRPr>
+            </a:pPr>
+            <a:r>
+              <a:t>29 hearts, 7 prayers</a:t>
             </a:r>
           </a:p>
         </p:txBody>
@@ -7801,30 +7443,30 @@
         </p:nvSpPr>
         <p:spPr>
           <a:xfrm>
-            <a:off x="1097280" y="5120640"/>
-            <a:ext cx="9966960" cy="457200"/>
-          </a:xfrm>
-          <a:prstGeom prst="rect">
-            <a:avLst/>
-          </a:prstGeom>
-          <a:noFill/>
-        </p:spPr>
-        <p:txBody>
-          <a:bodyPr wrap="square">
-            <a:spAutoFit/>
-          </a:bodyPr>
-          <a:lstStyle/>
-          <a:p>
-            <a:pPr algn="l">
-              <a:defRPr sz="1200" b="1" i="0">
-                <a:solidFill>
-                  <a:srgbClr val="06B6D4"/>
-                </a:solidFill>
-                <a:latin typeface="Calibri"/>
-              </a:defRPr>
-            </a:pPr>
-            <a:r>
-              <a:t>Leadership · Excellence</a:t>
+            <a:off x="1097280" y="5760720"/>
+            <a:ext cx="9966960" cy="274320"/>
+          </a:xfrm>
+          <a:prstGeom prst="rect">
+            <a:avLst/>
+          </a:prstGeom>
+          <a:noFill/>
+        </p:spPr>
+        <p:txBody>
+          <a:bodyPr wrap="square">
+            <a:spAutoFit/>
+          </a:bodyPr>
+          <a:lstStyle/>
+          <a:p>
+            <a:pPr algn="l">
+              <a:defRPr sz="1100" b="0" i="0">
+                <a:solidFill>
+                  <a:srgbClr val="5C6270"/>
+                </a:solidFill>
+                <a:latin typeface="Calibri"/>
+              </a:defRPr>
+            </a:pPr>
+            <a:r>
+              <a:t>#general</a:t>
             </a:r>
           </a:p>
         </p:txBody>
@@ -7870,7 +7512,7 @@
             <a:avLst/>
           </a:prstGeom>
           <a:solidFill>
-            <a:srgbClr val="84CC16"/>
+            <a:srgbClr val="059669"/>
           </a:solidFill>
           <a:ln>
             <a:noFill/>
@@ -7923,13 +7565,13 @@
             <a:pPr algn="l">
               <a:defRPr sz="1000" b="1">
                 <a:solidFill>
-                  <a:srgbClr val="84CC16"/>
-                </a:solidFill>
-                <a:latin typeface="Calibri"/>
-              </a:defRPr>
-            </a:pPr>
-            <a:r>
-              <a:t>🏆  CLAPS</a:t>
+                  <a:srgbClr val="059669"/>
+                </a:solidFill>
+                <a:latin typeface="Calibri"/>
+              </a:defRPr>
+            </a:pPr>
+            <a:r>
+              <a:t>🚀  WIN</a:t>
             </a:r>
           </a:p>
         </p:txBody>
@@ -7959,13 +7601,13 @@
             <a:pPr algn="l">
               <a:defRPr sz="3200" b="1" i="0">
                 <a:solidFill>
-                  <a:srgbClr val="84CC16"/>
-                </a:solidFill>
-                <a:latin typeface="Calibri"/>
-              </a:defRPr>
-            </a:pPr>
-            <a:r>
-              <a:t>Cross-Team Collaboration</a:t>
+                  <a:srgbClr val="059669"/>
+                </a:solidFill>
+                <a:latin typeface="Calibri"/>
+              </a:defRPr>
+            </a:pPr>
+            <a:r>
+              <a:t>Innovation Mindset</a:t>
             </a:r>
           </a:p>
         </p:txBody>
@@ -7979,29 +7621,29 @@
         <p:spPr>
           <a:xfrm>
             <a:off x="1097280" y="2103120"/>
-            <a:ext cx="2743200" cy="548640"/>
-          </a:xfrm>
-          <a:prstGeom prst="rect">
-            <a:avLst/>
-          </a:prstGeom>
-          <a:noFill/>
-        </p:spPr>
-        <p:txBody>
-          <a:bodyPr wrap="square">
-            <a:spAutoFit/>
-          </a:bodyPr>
-          <a:lstStyle/>
-          <a:p>
-            <a:pPr algn="l">
-              <a:defRPr sz="2800" b="1" i="0">
-                <a:solidFill>
-                  <a:srgbClr val="84CC16"/>
-                </a:solidFill>
-                <a:latin typeface="Calibri"/>
-              </a:defRPr>
-            </a:pPr>
-            <a:r>
-              <a:t>50</a:t>
+            <a:ext cx="4572000" cy="822960"/>
+          </a:xfrm>
+          <a:prstGeom prst="rect">
+            <a:avLst/>
+          </a:prstGeom>
+          <a:noFill/>
+        </p:spPr>
+        <p:txBody>
+          <a:bodyPr wrap="square">
+            <a:spAutoFit/>
+          </a:bodyPr>
+          <a:lstStyle/>
+          <a:p>
+            <a:pPr algn="l">
+              <a:defRPr sz="4800" b="1" i="0">
+                <a:solidFill>
+                  <a:srgbClr val="059669"/>
+                </a:solidFill>
+                <a:latin typeface="Calibri"/>
+              </a:defRPr>
+            </a:pPr>
+            <a:r>
+              <a:t>Many</a:t>
             </a:r>
           </a:p>
         </p:txBody>
@@ -8014,7 +7656,43 @@
         </p:nvSpPr>
         <p:spPr>
           <a:xfrm>
-            <a:off x="1097280" y="2651760"/>
+            <a:off x="1097280" y="2834640"/>
+            <a:ext cx="4572000" cy="365760"/>
+          </a:xfrm>
+          <a:prstGeom prst="rect">
+            <a:avLst/>
+          </a:prstGeom>
+          <a:noFill/>
+        </p:spPr>
+        <p:txBody>
+          <a:bodyPr wrap="square">
+            <a:spAutoFit/>
+          </a:bodyPr>
+          <a:lstStyle/>
+          <a:p>
+            <a:pPr algn="l">
+              <a:defRPr sz="1200" b="0" i="0">
+                <a:solidFill>
+                  <a:srgbClr val="8F95A3"/>
+                </a:solidFill>
+                <a:latin typeface="Calibri"/>
+              </a:defRPr>
+            </a:pPr>
+            <a:r>
+              <a:t>Tools Built</a:t>
+            </a:r>
+          </a:p>
+        </p:txBody>
+      </p:sp>
+      <p:sp>
+        <p:nvSpPr>
+          <p:cNvPr id="7" name="TextBox 6"/>
+          <p:cNvSpPr txBox="1"/>
+          <p:nvPr/>
+        </p:nvSpPr>
+        <p:spPr>
+          <a:xfrm>
+            <a:off x="1097280" y="3291840"/>
             <a:ext cx="9966960" cy="365760"/>
           </a:xfrm>
           <a:prstGeom prst="rect">
@@ -8037,35 +7715,35 @@
               </a:defRPr>
             </a:pPr>
             <a:r>
-              <a:t>from Alexandr Babich &amp; Sasha</a:t>
-            </a:r>
-          </a:p>
-        </p:txBody>
-      </p:sp>
-      <p:sp>
-        <p:nvSpPr>
-          <p:cNvPr id="7" name="TextBox 6"/>
-          <p:cNvSpPr txBox="1"/>
-          <p:nvPr/>
-        </p:nvSpPr>
-        <p:spPr>
-          <a:xfrm>
-            <a:off x="1097280" y="3108960"/>
-            <a:ext cx="9966960" cy="365760"/>
-          </a:xfrm>
-          <a:prstGeom prst="rect">
-            <a:avLst/>
-          </a:prstGeom>
-          <a:noFill/>
-        </p:spPr>
-        <p:txBody>
-          <a:bodyPr wrap="square">
-            <a:spAutoFit/>
-          </a:bodyPr>
-          <a:lstStyle/>
-          <a:p>
-            <a:pPr algn="l">
-              <a:defRPr sz="1400" b="1" i="0">
+              <a:t>by Non-Engineering Teams</a:t>
+            </a:r>
+          </a:p>
+        </p:txBody>
+      </p:sp>
+      <p:sp>
+        <p:nvSpPr>
+          <p:cNvPr id="8" name="TextBox 7"/>
+          <p:cNvSpPr txBox="1"/>
+          <p:nvPr/>
+        </p:nvSpPr>
+        <p:spPr>
+          <a:xfrm>
+            <a:off x="1097280" y="3840480"/>
+            <a:ext cx="9966960" cy="457200"/>
+          </a:xfrm>
+          <a:prstGeom prst="rect">
+            <a:avLst/>
+          </a:prstGeom>
+          <a:noFill/>
+        </p:spPr>
+        <p:txBody>
+          <a:bodyPr wrap="square">
+            <a:spAutoFit/>
+          </a:bodyPr>
+          <a:lstStyle/>
+          <a:p>
+            <a:pPr algn="l">
+              <a:defRPr sz="1800" b="1" i="0">
                 <a:solidFill>
                   <a:srgbClr val="FFFFFF"/>
                 </a:solidFill>
@@ -8073,35 +7751,35 @@
               </a:defRPr>
             </a:pPr>
             <a:r>
-              <a:t>to: Alexandr Babich, Sasha, Anna Timoshenko</a:t>
-            </a:r>
-          </a:p>
-        </p:txBody>
-      </p:sp>
-      <p:sp>
-        <p:nvSpPr>
-          <p:cNvPr id="8" name="TextBox 7"/>
-          <p:cNvSpPr txBox="1"/>
-          <p:nvPr/>
-        </p:nvSpPr>
-        <p:spPr>
-          <a:xfrm>
-            <a:off x="1097280" y="3749039"/>
-            <a:ext cx="9966960" cy="1097280"/>
-          </a:xfrm>
-          <a:prstGeom prst="rect">
-            <a:avLst/>
-          </a:prstGeom>
-          <a:noFill/>
-        </p:spPr>
-        <p:txBody>
-          <a:bodyPr wrap="square">
-            <a:spAutoFit/>
-          </a:bodyPr>
-          <a:lstStyle/>
-          <a:p>
-            <a:pPr algn="l">
-              <a:defRPr sz="1500" b="0" i="1">
+              <a:t>Non-technical teams building powerful tools</a:t>
+            </a:r>
+          </a:p>
+        </p:txBody>
+      </p:sp>
+      <p:sp>
+        <p:nvSpPr>
+          <p:cNvPr id="9" name="TextBox 8"/>
+          <p:cNvSpPr txBox="1"/>
+          <p:nvPr/>
+        </p:nvSpPr>
+        <p:spPr>
+          <a:xfrm>
+            <a:off x="1097280" y="4389120"/>
+            <a:ext cx="9966960" cy="914400"/>
+          </a:xfrm>
+          <a:prstGeom prst="rect">
+            <a:avLst/>
+          </a:prstGeom>
+          <a:noFill/>
+        </p:spPr>
+        <p:txBody>
+          <a:bodyPr wrap="square">
+            <a:spAutoFit/>
+          </a:bodyPr>
+          <a:lstStyle/>
+          <a:p>
+            <a:pPr algn="l">
+              <a:defRPr sz="1400" b="0" i="0">
                 <a:solidFill>
                   <a:srgbClr val="E2E2EA"/>
                 </a:solidFill>
@@ -8109,20 +7787,20 @@
               </a:defRPr>
             </a:pPr>
             <a:r>
-              <a:t>"Excellent teamwork and mutual recognition showing strong collaborative culture"</a:t>
-            </a:r>
-          </a:p>
-        </p:txBody>
-      </p:sp>
-      <p:sp>
-        <p:nvSpPr>
-          <p:cNvPr id="9" name="TextBox 8"/>
-          <p:cNvSpPr txBox="1"/>
-          <p:nvPr/>
-        </p:nvSpPr>
-        <p:spPr>
-          <a:xfrm>
-            <a:off x="1097280" y="5120640"/>
+              <a:t>We're seeing incredible innovation as non-engineering teams rapidly create useful tools, showing we're learning fast and moving in the right direction.</a:t>
+            </a:r>
+          </a:p>
+        </p:txBody>
+      </p:sp>
+      <p:sp>
+        <p:nvSpPr>
+          <p:cNvPr id="10" name="TextBox 9"/>
+          <p:cNvSpPr txBox="1"/>
+          <p:nvPr/>
+        </p:nvSpPr>
+        <p:spPr>
+          <a:xfrm>
+            <a:off x="1097280" y="5486400"/>
             <a:ext cx="9966960" cy="457200"/>
           </a:xfrm>
           <a:prstGeom prst="rect">
@@ -8137,15 +7815,15 @@
           <a:lstStyle/>
           <a:p>
             <a:pPr algn="l">
-              <a:defRPr sz="1200" b="1" i="0">
-                <a:solidFill>
-                  <a:srgbClr val="84CC16"/>
-                </a:solidFill>
-                <a:latin typeface="Calibri"/>
-              </a:defRPr>
-            </a:pPr>
-            <a:r>
-              <a:t>Collaboration · Support</a:t>
+              <a:defRPr sz="1300" b="0" i="1">
+                <a:solidFill>
+                  <a:srgbClr val="8F95A3"/>
+                </a:solidFill>
+                <a:latin typeface="Calibri"/>
+              </a:defRPr>
+            </a:pPr>
+            <a:r>
+              <a:t>💬 "This demonstrates our culture of empowerment and rapid learning across all functions"</a:t>
             </a:r>
           </a:p>
         </p:txBody>
@@ -8191,7 +7869,7 @@
             <a:avLst/>
           </a:prstGeom>
           <a:solidFill>
-            <a:srgbClr val="8B5CF6"/>
+            <a:srgbClr val="7C2D12"/>
           </a:solidFill>
           <a:ln>
             <a:noFill/>
@@ -8244,13 +7922,13 @@
             <a:pPr algn="l">
               <a:defRPr sz="1000" b="1">
                 <a:solidFill>
-                  <a:srgbClr val="8B5CF6"/>
-                </a:solidFill>
-                <a:latin typeface="Calibri"/>
-              </a:defRPr>
-            </a:pPr>
-            <a:r>
-              <a:t>💪  CLAPS</a:t>
+                  <a:srgbClr val="7C2D12"/>
+                </a:solidFill>
+                <a:latin typeface="Calibri"/>
+              </a:defRPr>
+            </a:pPr>
+            <a:r>
+              <a:t>🔒  EVENT</a:t>
             </a:r>
           </a:p>
         </p:txBody>
@@ -8280,13 +7958,13 @@
             <a:pPr algn="l">
               <a:defRPr sz="3200" b="1" i="0">
                 <a:solidFill>
-                  <a:srgbClr val="8B5CF6"/>
-                </a:solidFill>
-                <a:latin typeface="Calibri"/>
-              </a:defRPr>
-            </a:pPr>
-            <a:r>
-              <a:t>Technical Excellence</a:t>
+                  <a:srgbClr val="7C2D12"/>
+                </a:solidFill>
+                <a:latin typeface="Calibri"/>
+              </a:defRPr>
+            </a:pPr>
+            <a:r>
+              <a:t>Engineering Standards</a:t>
             </a:r>
           </a:p>
         </p:txBody>
@@ -8300,29 +7978,29 @@
         <p:spPr>
           <a:xfrm>
             <a:off x="1097280" y="2103120"/>
-            <a:ext cx="2743200" cy="548640"/>
-          </a:xfrm>
-          <a:prstGeom prst="rect">
-            <a:avLst/>
-          </a:prstGeom>
-          <a:noFill/>
-        </p:spPr>
-        <p:txBody>
-          <a:bodyPr wrap="square">
-            <a:spAutoFit/>
-          </a:bodyPr>
-          <a:lstStyle/>
-          <a:p>
-            <a:pPr algn="l">
-              <a:defRPr sz="2800" b="1" i="0">
-                <a:solidFill>
-                  <a:srgbClr val="8B5CF6"/>
-                </a:solidFill>
-                <a:latin typeface="Calibri"/>
-              </a:defRPr>
-            </a:pPr>
-            <a:r>
-              <a:t>25</a:t>
+            <a:ext cx="9966960" cy="548640"/>
+          </a:xfrm>
+          <a:prstGeom prst="rect">
+            <a:avLst/>
+          </a:prstGeom>
+          <a:noFill/>
+        </p:spPr>
+        <p:txBody>
+          <a:bodyPr wrap="square">
+            <a:spAutoFit/>
+          </a:bodyPr>
+          <a:lstStyle/>
+          <a:p>
+            <a:pPr algn="l">
+              <a:defRPr sz="2200" b="1" i="0">
+                <a:solidFill>
+                  <a:srgbClr val="FFFFFF"/>
+                </a:solidFill>
+                <a:latin typeface="Calibri"/>
+              </a:defRPr>
+            </a:pPr>
+            <a:r>
+              <a:t>Security &amp; Deployment Best Practices</a:t>
             </a:r>
           </a:p>
         </p:txBody>
@@ -8335,7 +8013,7 @@
         </p:nvSpPr>
         <p:spPr>
           <a:xfrm>
-            <a:off x="1097280" y="2651760"/>
+            <a:off x="1097280" y="2743200"/>
             <a:ext cx="9966960" cy="365760"/>
           </a:xfrm>
           <a:prstGeom prst="rect">
@@ -8350,7 +8028,43 @@
           <a:lstStyle/>
           <a:p>
             <a:pPr algn="l">
-              <a:defRPr sz="1400" b="0" i="0">
+              <a:defRPr sz="1400" b="1" i="0">
+                <a:solidFill>
+                  <a:srgbClr val="7C2D12"/>
+                </a:solidFill>
+                <a:latin typeface="Calibri"/>
+              </a:defRPr>
+            </a:pPr>
+            <a:r>
+              <a:t>Now Active</a:t>
+            </a:r>
+          </a:p>
+        </p:txBody>
+      </p:sp>
+      <p:sp>
+        <p:nvSpPr>
+          <p:cNvPr id="7" name="TextBox 6"/>
+          <p:cNvSpPr txBox="1"/>
+          <p:nvPr/>
+        </p:nvSpPr>
+        <p:spPr>
+          <a:xfrm>
+            <a:off x="1097280" y="3291840"/>
+            <a:ext cx="9966960" cy="1371600"/>
+          </a:xfrm>
+          <a:prstGeom prst="rect">
+            <a:avLst/>
+          </a:prstGeom>
+          <a:noFill/>
+        </p:spPr>
+        <p:txBody>
+          <a:bodyPr wrap="square">
+            <a:spAutoFit/>
+          </a:bodyPr>
+          <a:lstStyle/>
+          <a:p>
+            <a:pPr algn="l">
+              <a:defRPr sz="1500" b="0" i="0">
                 <a:solidFill>
                   <a:srgbClr val="E2E2EA"/>
                 </a:solidFill>
@@ -8358,20 +8072,20 @@
               </a:defRPr>
             </a:pPr>
             <a:r>
-              <a:t>from Sergey Orlov &amp; Iurii Kotov</a:t>
-            </a:r>
-          </a:p>
-        </p:txBody>
-      </p:sp>
-      <p:sp>
-        <p:nvSpPr>
-          <p:cNvPr id="7" name="TextBox 6"/>
-          <p:cNvSpPr txBox="1"/>
-          <p:nvPr/>
-        </p:nvSpPr>
-        <p:spPr>
-          <a:xfrm>
-            <a:off x="1097280" y="3108960"/>
+              <a:t>As we scale, we're implementing proper engineering and security practices with managed deployments to ensure sustainable growth.</a:t>
+            </a:r>
+          </a:p>
+        </p:txBody>
+      </p:sp>
+      <p:sp>
+        <p:nvSpPr>
+          <p:cNvPr id="8" name="TextBox 7"/>
+          <p:cNvSpPr txBox="1"/>
+          <p:nvPr/>
+        </p:nvSpPr>
+        <p:spPr>
+          <a:xfrm>
+            <a:off x="1097280" y="5029200"/>
             <a:ext cx="9966960" cy="365760"/>
           </a:xfrm>
           <a:prstGeom prst="rect">
@@ -8386,87 +8100,15 @@
           <a:lstStyle/>
           <a:p>
             <a:pPr algn="l">
-              <a:defRPr sz="1400" b="1" i="0">
-                <a:solidFill>
-                  <a:srgbClr val="FFFFFF"/>
-                </a:solidFill>
-                <a:latin typeface="Calibri"/>
-              </a:defRPr>
-            </a:pPr>
-            <a:r>
-              <a:t>to: Roman de las Heras, Ana Abuseridze, Dima M.</a:t>
-            </a:r>
-          </a:p>
-        </p:txBody>
-      </p:sp>
-      <p:sp>
-        <p:nvSpPr>
-          <p:cNvPr id="8" name="TextBox 7"/>
-          <p:cNvSpPr txBox="1"/>
-          <p:nvPr/>
-        </p:nvSpPr>
-        <p:spPr>
-          <a:xfrm>
-            <a:off x="1097280" y="3749039"/>
-            <a:ext cx="9966960" cy="1097280"/>
-          </a:xfrm>
-          <a:prstGeom prst="rect">
-            <a:avLst/>
-          </a:prstGeom>
-          <a:noFill/>
-        </p:spPr>
-        <p:txBody>
-          <a:bodyPr wrap="square">
-            <a:spAutoFit/>
-          </a:bodyPr>
-          <a:lstStyle/>
-          <a:p>
-            <a:pPr algn="l">
-              <a:defRPr sz="1500" b="0" i="1">
-                <a:solidFill>
-                  <a:srgbClr val="E2E2EA"/>
-                </a:solidFill>
-                <a:latin typeface="Calibri"/>
-              </a:defRPr>
-            </a:pPr>
-            <a:r>
-              <a:t>"Outstanding technical contributions and problem-solving skills"</a:t>
-            </a:r>
-          </a:p>
-        </p:txBody>
-      </p:sp>
-      <p:sp>
-        <p:nvSpPr>
-          <p:cNvPr id="9" name="TextBox 8"/>
-          <p:cNvSpPr txBox="1"/>
-          <p:nvPr/>
-        </p:nvSpPr>
-        <p:spPr>
-          <a:xfrm>
-            <a:off x="1097280" y="5120640"/>
-            <a:ext cx="9966960" cy="457200"/>
-          </a:xfrm>
-          <a:prstGeom prst="rect">
-            <a:avLst/>
-          </a:prstGeom>
-          <a:noFill/>
-        </p:spPr>
-        <p:txBody>
-          <a:bodyPr wrap="square">
-            <a:spAutoFit/>
-          </a:bodyPr>
-          <a:lstStyle/>
-          <a:p>
-            <a:pPr algn="l">
-              <a:defRPr sz="1200" b="1" i="0">
-                <a:solidFill>
-                  <a:srgbClr val="8B5CF6"/>
-                </a:solidFill>
-                <a:latin typeface="Calibri"/>
-              </a:defRPr>
-            </a:pPr>
-            <a:r>
-              <a:t>Innovation · Excellence</a:t>
+              <a:defRPr sz="1300" b="0" i="0">
+                <a:solidFill>
+                  <a:srgbClr val="8F95A3"/>
+                </a:solidFill>
+                <a:latin typeface="Calibri"/>
+              </a:defRPr>
+            </a:pPr>
+            <a:r>
+              <a:t>Organized by Engineering Team</a:t>
             </a:r>
           </a:p>
         </p:txBody>

</xml_diff>